<commit_message>
KI-Tag: 40-min keynote, station worksheets and teacher guide
Shorten the keynote to ~40 minutes, add the speaker photo and
Mentimeter cues, and add printable worksheets for the five workshop
stations plus a teacher guide with rotation plan and solutions.

Co-Authored-By: Claude Opus 5.5 <noreply@anthropic.com>
Claude-Session: https://claude.ai/code/session_01H9eHZaZTrpoTKHBqh2YYjW
</commit_message>
<xml_diff>
--- a/ki-tag-gymnasium-sued/KI-Tag_Gymnasium-Sued_Impulsvortrag.pptx
+++ b/ki-tag-gymnasium-sued/KI-Tag_Gymnasium-Sued_Impulsvortrag.pptx
@@ -124,14 +124,14 @@
   <p:extLst>
     <p:ext uri="{521415D9-36F7-43E2-AB2F-B90AF26B5E84}">
       <p14:sectionLst xmlns:p14="http://schemas.microsoft.com/office/powerpoint/2010/main">
-        <p14:section name="Einstieg" id="{487de1be-8881-0cb9-20b1-29c830392adc}">
+        <p14:section name="Einstieg" id="{09d5822b-ffae-f4ed-28bf-61eb1a0668b1}">
           <p14:sldIdLst>
             <p14:sldId id="256"/>
             <p14:sldId id="257"/>
             <p14:sldId id="258"/>
           </p14:sldIdLst>
         </p14:section>
-        <p14:section name="Staunen" id="{7f27db10-b426-598d-46e6-884295fa5e30}">
+        <p14:section name="Staunen" id="{ee41868e-a216-0975-f3f2-d390d7f9087d}">
           <p14:sldIdLst>
             <p14:sldId id="259"/>
             <p14:sldId id="260"/>
@@ -139,28 +139,28 @@
             <p14:sldId id="262"/>
           </p14:sldIdLst>
         </p14:section>
-        <p14:section name="Verstehen" id="{e28ce41e-6169-a820-b944-34c441a6913e}">
+        <p14:section name="Verstehen" id="{54995c5c-f9a3-78d8-230a-7214a073b547}">
           <p14:sldIdLst>
             <p14:sldId id="263"/>
             <p14:sldId id="264"/>
             <p14:sldId id="265"/>
           </p14:sldIdLst>
         </p14:section>
-        <p14:section name="Chancen" id="{7265d999-360c-d316-6876-40f12b67b8d8}">
+        <p14:section name="Chancen" id="{b9e0f019-2c7e-b66d-37c5-46b66b26a3c6}">
           <p14:sldIdLst>
             <p14:sldId id="266"/>
             <p14:sldId id="267"/>
             <p14:sldId id="268"/>
           </p14:sldIdLst>
         </p14:section>
-        <p14:section name="Risiken &amp; Verantwortung" id="{e776f60e-ef37-0fe4-59e5-fe62852ed467}">
+        <p14:section name="Risiken &amp; Verantwortung" id="{ddd1200e-0409-3c0f-b771-40b8fd76fcb4}">
           <p14:sldIdLst>
             <p14:sldId id="269"/>
             <p14:sldId id="270"/>
             <p14:sldId id="271"/>
           </p14:sldIdLst>
         </p14:section>
-        <p14:section name="Workshop &amp; Abschluss" id="{48ff71ce-9a76-ab47-9640-b9110ed8a429}">
+        <p14:section name="Workshop &amp; Abschluss" id="{62ee86b1-8d63-d0e8-6fa0-5315ed9aa182}">
           <p14:sldIdLst>
             <p14:sldId id="272"/>
             <p14:sldId id="273"/>
@@ -805,7 +805,7 @@
           <a:p>
             <a:r>
               <a:rPr lang="en-US" dirty="0"/>
-              <a:t>Begrüßung (ca. 1 Min.). Thema des Tages: KI verstehen, ausprobieren, einordnen. Das Bild rechts ist die Idee des Tages: Mensch und KI zusammen – nicht gegeneinander.</a:t>
+              <a:t>Begrüßung (ca. 30 Sek.). Thema des Tages: KI verstehen, ausprobieren, einordnen. Das Bild rechts ist die Idee des Tages: Mensch und KI zusammen – nicht gegeneinander.</a:t>
             </a:r>
             <a:endParaRPr lang="en-US" dirty="0"/>
           </a:p>
@@ -893,7 +893,7 @@
           <a:p>
             <a:r>
               <a:rPr lang="en-US" dirty="0"/>
-              <a:t>Ca. 5 Min. Am besten durch ein echtes Beispiel aus der Live-Demo ersetzen oder ergänzen (KI live nach einer Quelle fragen und gemeinsam prüfen). Merksatz: Sprachliche Sicherheit ist kein Beweis für Wahrheit.</a:t>
+              <a:t>Ca. 3 Min. Am besten durch ein echtes Beispiel aus der Live-Demo ersetzen oder ergänzen (KI live nach einer Quelle fragen und gemeinsam prüfen). Merksatz: Sprachliche Sicherheit ist kein Beweis für Wahrheit.</a:t>
             </a:r>
             <a:endParaRPr lang="en-US" dirty="0"/>
           </a:p>
@@ -981,7 +981,7 @@
           <a:p>
             <a:r>
               <a:rPr lang="en-US" dirty="0"/>
-              <a:t>Übergang zu Teil 3 (ca. 30 Sek.).</a:t>
+              <a:t>Übergang zu Teil 3 (ca. 15 Sek.).</a:t>
             </a:r>
             <a:endParaRPr lang="en-US" dirty="0"/>
           </a:p>
@@ -1069,7 +1069,7 @@
           <a:p>
             <a:r>
               <a:rPr lang="en-US" dirty="0"/>
-              <a:t>Ca. 5 Min. Den Unterschied der beiden Prompts unten betonen: Gleiches Werkzeug, völlig anderer Lerneffekt. Verweis auf Station 2 (KI als Lerncoach) und Station 1 (Prompt Battle).</a:t>
+              <a:t>Ca. 3 Min. Den Unterschied der beiden Prompts unten betonen: Gleiches Werkzeug, völlig anderer Lerneffekt. Verweis auf Station 2 (KI als Lerncoach) und Station 1 (Prompt Battle).</a:t>
             </a:r>
             <a:endParaRPr lang="en-US" dirty="0"/>
           </a:p>
@@ -1157,7 +1157,7 @@
           <a:p>
             <a:r>
               <a:rPr lang="en-US" dirty="0"/>
-              <a:t>Ca. 4 Min. Grafik kurz lesen helfen: rechts oben = heute wichtig UND wird noch wichtiger. KI und Big Data ganz oben – aber direkt daneben kreatives Denken, Resilienz, Neugier. Botschaft: Wer KI beherrscht UND menschliche Stärken trainiert, ist für die Zukunft gut aufgestellt.</a:t>
+              <a:t>Ca. 2 Min. Grafik kurz lesen helfen: rechts oben = heute wichtig UND wird noch wichtiger. KI und Big Data ganz oben – aber direkt daneben kreatives Denken, Resilienz, Neugier. Botschaft: Wer KI beherrscht UND menschliche Stärken trainiert, ist für die Zukunft gut aufgestellt.</a:t>
             </a:r>
             <a:endParaRPr lang="en-US" dirty="0"/>
           </a:p>
@@ -1245,7 +1245,7 @@
           <a:p>
             <a:r>
               <a:rPr lang="en-US" dirty="0"/>
-              <a:t>Übergang zu Teil 4 (ca. 30 Sek.).</a:t>
+              <a:t>Übergang zu Teil 4 (ca. 15 Sek.).</a:t>
             </a:r>
             <a:endParaRPr lang="en-US" dirty="0"/>
           </a:p>
@@ -1333,7 +1333,7 @@
           <a:p>
             <a:r>
               <a:rPr lang="en-US" dirty="0"/>
-              <a:t>Ca. 6 Min. Deepfakes am besten mit einem echten Beispiel zeigen (Bild oder Video, ‚echt oder KI?‘) – Überleitung zu Station 4 (Deepfake Detective). Datenschutz: Nutzungsbedingungen/Altersgrenzen der Tools und die Regeln der Schule ansprechen.</a:t>
+              <a:t>Ca. 4 Min. Vorher Menti-Frage 4 stellen: Wie sicher erkennst du, ob ein Bild echt ist? Ergebnis merken – an Station 4 wird das überprüft. Deepfakes am besten mit einem echten Beispiel zeigen (Bild oder Video, ‚echt oder KI?‘) – Überleitung zu Station 4 (Deepfake Detective). Datenschutz: Nutzungsbedingungen/Altersgrenzen der Tools und die Regeln der Schule ansprechen.</a:t>
             </a:r>
             <a:endParaRPr lang="en-US" dirty="0"/>
           </a:p>
@@ -1421,7 +1421,7 @@
           <a:p>
             <a:r>
               <a:rPr lang="en-US" dirty="0"/>
-              <a:t>Ca. 3 Min. Kernbotschaft des Vortrags: Die stärkste Kombination ist Mensch + KI. Die KI liefert Tempo und Menge, der Mensch Urteil und Verantwortung. Wer prüft, wer entscheidet? Immer ihr.</a:t>
+              <a:t>Ca. 2 Min. Kernbotschaft des Vortrags: Die stärkste Kombination ist Mensch + KI. Die KI liefert Tempo und Menge, der Mensch Urteil und Verantwortung. Wer prüft, wer entscheidet? Immer ihr.</a:t>
             </a:r>
             <a:endParaRPr lang="en-US" dirty="0"/>
           </a:p>
@@ -1509,7 +1509,7 @@
           <a:p>
             <a:r>
               <a:rPr lang="en-US" dirty="0"/>
-              <a:t>Ca. 3 Min. Stationen kurz vorstellen, Gruppeneinteilung und Rotation erklären (wer startet wo, Signal zum Wechseln, Pause nach Station … ). Die Stationen sind vorbereitet und können selbstständig oder mit Begleitung durch Lehrkräfte bearbeitet werden.</a:t>
+              <a:t>Ca. 2 Min. Stationen kurz vorstellen, Gruppeneinteilung und Rotation erklären (wer startet wo, Signal zum Wechseln, Pause nach Station … ). Die Stationen sind vorbereitet und können selbstständig oder mit Begleitung durch Lehrkräfte bearbeitet werden.</a:t>
             </a:r>
             <a:endParaRPr lang="en-US" dirty="0"/>
           </a:p>
@@ -1597,7 +1597,7 @@
           <a:p>
             <a:r>
               <a:rPr lang="en-US" dirty="0"/>
-              <a:t>Ca. 2 Min. Leitidee laut vorlesen und als Auftrag für den Parcours mitgeben. Kurze Fragerunde, dann Wechsel zu den Stationen.</a:t>
+              <a:t>Ca. 2,5 Min. Leitidee laut vorlesen und als Auftrag für den Parcours mitgeben. Menti-Frage 5 (Was nimmst du mit?) – gerne auch am Ende des Tages nochmal öffnen. Kurze Fragerunde, dann Wechsel zu den Stationen. Gesamtzeit Impuls: ca. 40 Min.</a:t>
             </a:r>
             <a:endParaRPr lang="en-US" dirty="0"/>
           </a:p>
@@ -1685,7 +1685,7 @@
           <a:p>
             <a:r>
               <a:rPr lang="en-US" dirty="0"/>
-              <a:t>Kurz vorstellen (1 Min.), dann Umfrage per Handzeichen (2–3 Min.). Ergebnisse spiegeln: Die meisten nutzen KI schon – heute geht es darum, sie gut und kritisch zu nutzen. Alternative: Live-Umfrage per Mentimeter.</a:t>
+              <a:t>Ca. 4 Min. Kurz vorstellen (1 Min.). Dann zu Mentimeter wechseln: Menti-Frage 1 (Wortwolke: Woran denkst du bei KI?) und Menti-Frage 2 (Wofür hast du KI schon genutzt?). Ergebnisse kurz spiegeln: Die meisten nutzen KI schon – heute geht es darum, sie gut und kritisch zu nutzen.</a:t>
             </a:r>
             <a:endParaRPr lang="en-US" dirty="0"/>
           </a:p>
@@ -1773,7 +1773,7 @@
           <a:p>
             <a:r>
               <a:rPr lang="en-US" dirty="0"/>
-              <a:t>Ablauf erklären (ca. 2 Min.): Impuls in vier Teilen, danach Workshop-Parcours in 5 Gruppen à ca. 11 Personen. Durchlauf 1: Impuls 08:15–09:15, Workshop 09:15–12:00. Durchlauf 2: Impuls 12:05–13:05, Workshop 13:05–15:50.</a:t>
+              <a:t>Ablauf erklären (ca. 1 Min.): Impuls in vier Teilen, danach Workshop-Parcours in 5 Gruppen à ca. 11 Personen. Durchlauf 1: Impuls 08:15–09:15, Workshop 09:15–12:00. Durchlauf 2: Impuls 12:05–13:05, Workshop 13:05–15:50.</a:t>
             </a:r>
             <a:endParaRPr lang="en-US" dirty="0"/>
           </a:p>
@@ -1861,7 +1861,7 @@
           <a:p>
             <a:r>
               <a:rPr lang="en-US" dirty="0"/>
-              <a:t>Übergang zu Teil 1 (ca. 30 Sek.).</a:t>
+              <a:t>Übergang zu Teil 1 (ca. 15 Sek.).</a:t>
             </a:r>
             <a:endParaRPr lang="en-US" dirty="0"/>
           </a:p>
@@ -1949,7 +1949,7 @@
           <a:p>
             <a:r>
               <a:rPr lang="en-US" dirty="0"/>
-              <a:t>Ca. 3 Min. Frage ans Publikum: Was glaubt ihr, wie lange hat ChatGPT für 1 Million Nutzer gebraucht? Erst raten lassen, dann auflösen. Botschaft: KI ist nicht ‚irgendwann‘, sie ist schon im Alltag angekommen.</a:t>
+              <a:t>Ca. 2,5 Min. Folie erst ausblenden (schwarz, Taste B) und Menti-Frage 3 stellen: Wie lange hat ChatGPT für 1 Million Nutzer gebraucht? Abstimmen lassen, dann diese Folie zeigen und auflösen. Botschaft: KI ist nicht ‚irgendwann‘, sie ist schon im Alltag angekommen.</a:t>
             </a:r>
             <a:endParaRPr lang="en-US" dirty="0"/>
           </a:p>
@@ -2037,7 +2037,7 @@
           <a:p>
             <a:r>
               <a:rPr lang="en-US" dirty="0"/>
-              <a:t>Kernstück von Teil 1 (ca. 10–12 Min.). Live am Beamer zeigen, Aufgaben möglichst aus dem Publikum nehmen. Vorher testen: WLAN, Logins, Tools. Backup: Screenshots/Videos der Demos, falls das Netz ausfällt.</a:t>
+              <a:t>Kernstück von Teil 1 (ca. 7 Min., max. 2 Demos ausführlich, den Rest kurz). Live am Beamer zeigen, Aufgaben möglichst aus dem Publikum nehmen. Vorher testen: WLAN, Logins, Tools. Backup: Screenshots/Videos der Demos, falls das Netz ausfällt.</a:t>
             </a:r>
             <a:endParaRPr lang="en-US" dirty="0"/>
           </a:p>
@@ -2125,7 +2125,7 @@
           <a:p>
             <a:r>
               <a:rPr lang="en-US" dirty="0"/>
-              <a:t>Ca. 3 Min. Die Glockenkurve zeigt, wie Menschen in IQ-Tests verteilt sind (Durchschnitt 100). Die Logos sind KI-Modelle. 2024 lagen die besten Modelle noch unter dem Durchschnitt, ein Jahr später weit darüber. Wichtig: Ein IQ-Test misst nur einen kleinen Teil von Intelligenz – Urteilsvermögen, Verantwortung oder Empathie misst er nicht. Das führt zu Teil 2.</a:t>
+              <a:t>Ca. 2 Min. Die Glockenkurve zeigt, wie Menschen in IQ-Tests verteilt sind (Durchschnitt 100). Die Logos sind KI-Modelle. 2024 lagen die besten Modelle noch unter dem Durchschnitt, ein Jahr später weit darüber. Wichtig: Ein IQ-Test misst nur einen kleinen Teil von Intelligenz – Urteilsvermögen, Verantwortung oder Empathie misst er nicht. Das führt zu Teil 2.</a:t>
             </a:r>
             <a:endParaRPr lang="en-US" dirty="0"/>
           </a:p>
@@ -2213,7 +2213,7 @@
           <a:p>
             <a:r>
               <a:rPr lang="en-US" dirty="0"/>
-              <a:t>Übergang zu Teil 2 (ca. 30 Sek.).</a:t>
+              <a:t>Übergang zu Teil 2 (ca. 15 Sek.).</a:t>
             </a:r>
             <a:endParaRPr lang="en-US" dirty="0"/>
           </a:p>
@@ -2301,7 +2301,7 @@
           <a:p>
             <a:r>
               <a:rPr lang="en-US" dirty="0"/>
-              <a:t>Ca. 6 Min. Mitmachen lassen: ‚Der Himmel ist heute …‘ – Klasse ergänzt. Genau das macht die KI, nur mit Milliarden Texten. Konsequenz: Sie produziert, was wahrscheinlich KLINGT, nicht, was geprüft WAHR ist.</a:t>
+              <a:t>Ca. 3,5 Min. Mitmachen lassen: ‚Der Himmel ist heute …‘ – Klasse ergänzt. Genau das macht die KI, nur mit Milliarden Texten. Konsequenz: Sie produziert, was wahrscheinlich KLINGT, nicht, was geprüft WAHR ist.</a:t>
             </a:r>
             <a:endParaRPr lang="en-US" dirty="0"/>
           </a:p>
@@ -7515,6 +7515,64 @@
       </p:sp>
       <p:sp>
         <p:nvSpPr>
+          <p:cNvPr id="28" name="Hinweis Menti-Frage 4"/>
+          <p:cNvSpPr/>
+          <p:nvPr/>
+        </p:nvSpPr>
+        <p:spPr>
+          <a:xfrm>
+            <a:off x="9144000" y="6336792"/>
+            <a:ext cx="1783080" cy="274320"/>
+          </a:xfrm>
+          <a:prstGeom prst="roundRect">
+            <a:avLst>
+              <a:gd name="adj" fmla="val 20000"/>
+            </a:avLst>
+          </a:prstGeom>
+          <a:solidFill>
+            <a:schemeClr val="accent1"/>
+          </a:solidFill>
+          <a:ln/>
+        </p:spPr>
+      </p:sp>
+      <p:sp>
+        <p:nvSpPr>
+          <p:cNvPr id="29" name="Text 23"/>
+          <p:cNvSpPr txBox="1"/>
+          <p:nvPr/>
+        </p:nvSpPr>
+        <p:spPr>
+          <a:xfrm>
+            <a:off x="9144000" y="6336792"/>
+            <a:ext cx="1783080" cy="274320"/>
+          </a:xfrm>
+          <a:prstGeom prst="rect">
+            <a:avLst/>
+          </a:prstGeom>
+          <a:noFill/>
+          <a:ln/>
+        </p:spPr>
+        <p:txBody>
+          <a:bodyPr wrap="square" lIns="0" tIns="0" rIns="0" bIns="0" rtlCol="0" anchor="ctr"/>
+          <a:lstStyle/>
+          <a:p>
+            <a:pPr algn="ctr" indent="0" marL="0">
+              <a:buNone/>
+            </a:pPr>
+            <a:r>
+              <a:rPr lang="en-US" sz="1000" b="1" spc="200" kern="0" dirty="0">
+                <a:solidFill>
+                  <a:schemeClr val="bg1"/>
+                </a:solidFill>
+              </a:rPr>
+              <a:t>MENTI-FRAGE 4</a:t>
+            </a:r>
+            <a:endParaRPr lang="en-US" sz="1000" dirty="0"/>
+          </a:p>
+        </p:txBody>
+      </p:sp>
+      <p:sp>
+        <p:nvSpPr>
           <p:cNvPr id="25" name="Slide Number Placeholder 0"/>
           <p:cNvSpPr>
             <a:spLocks noGrp="1"/>
@@ -9501,6 +9559,64 @@
           </a:p>
         </p:txBody>
       </p:sp>
+      <p:sp>
+        <p:nvSpPr>
+          <p:cNvPr id="8" name="Hinweis Menti-Frage 5"/>
+          <p:cNvSpPr/>
+          <p:nvPr/>
+        </p:nvSpPr>
+        <p:spPr>
+          <a:xfrm>
+            <a:off x="9144000" y="6336792"/>
+            <a:ext cx="1783080" cy="274320"/>
+          </a:xfrm>
+          <a:prstGeom prst="roundRect">
+            <a:avLst>
+              <a:gd name="adj" fmla="val 20000"/>
+            </a:avLst>
+          </a:prstGeom>
+          <a:solidFill>
+            <a:schemeClr val="accent1"/>
+          </a:solidFill>
+          <a:ln/>
+        </p:spPr>
+      </p:sp>
+      <p:sp>
+        <p:nvSpPr>
+          <p:cNvPr id="9" name="Text 7"/>
+          <p:cNvSpPr txBox="1"/>
+          <p:nvPr/>
+        </p:nvSpPr>
+        <p:spPr>
+          <a:xfrm>
+            <a:off x="9144000" y="6336792"/>
+            <a:ext cx="1783080" cy="274320"/>
+          </a:xfrm>
+          <a:prstGeom prst="rect">
+            <a:avLst/>
+          </a:prstGeom>
+          <a:noFill/>
+          <a:ln/>
+        </p:spPr>
+        <p:txBody>
+          <a:bodyPr wrap="square" lIns="0" tIns="0" rIns="0" bIns="0" rtlCol="0" anchor="ctr"/>
+          <a:lstStyle/>
+          <a:p>
+            <a:pPr algn="ctr" indent="0" marL="0">
+              <a:buNone/>
+            </a:pPr>
+            <a:r>
+              <a:rPr lang="en-US" sz="1000" b="1" spc="200" kern="0" dirty="0">
+                <a:solidFill>
+                  <a:schemeClr val="bg1"/>
+                </a:solidFill>
+              </a:rPr>
+              <a:t>MENTI-FRAGE 5</a:t>
+            </a:r>
+            <a:endParaRPr lang="en-US" sz="1000" dirty="0"/>
+          </a:p>
+        </p:txBody>
+      </p:sp>
     </p:spTree>
   </p:cSld>
   <p:clrMapOvr>
@@ -9596,7 +9712,7 @@
                   <a:schemeClr val="tx2"/>
                 </a:solidFill>
               </a:rPr>
-              <a:t>Wer heute vor euch steht – und eine kurze Umfrage per Handzeichen</a:t>
+              <a:t>Wer heute vor euch steht – und eure Meinung per Mentimeter</a:t>
             </a:r>
             <a:endParaRPr lang="en-US" sz="1600" dirty="0"/>
           </a:p>
@@ -9624,193 +9740,9 @@
           <a:ln/>
         </p:spPr>
       </p:sp>
-      <p:sp>
-        <p:nvSpPr>
-          <p:cNvPr id="5" name="Foto-Platzhalter (durch Foto ersetzen)"/>
-          <p:cNvSpPr/>
-          <p:nvPr/>
-        </p:nvSpPr>
-        <p:spPr>
-          <a:xfrm>
-            <a:off x="914400" y="2194560"/>
-            <a:ext cx="1463040" cy="1463040"/>
-          </a:xfrm>
-          <a:prstGeom prst="ellipse">
-            <a:avLst/>
-          </a:prstGeom>
-          <a:solidFill>
-            <a:schemeClr val="tx1"/>
-          </a:solidFill>
-          <a:ln/>
-        </p:spPr>
-      </p:sp>
-      <p:sp>
-        <p:nvSpPr>
-          <p:cNvPr id="6" name="Text 4"/>
-          <p:cNvSpPr txBox="1"/>
-          <p:nvPr/>
-        </p:nvSpPr>
-        <p:spPr>
-          <a:xfrm>
-            <a:off x="914400" y="2194560"/>
-            <a:ext cx="1463040" cy="1463040"/>
-          </a:xfrm>
-          <a:prstGeom prst="rect">
-            <a:avLst/>
-          </a:prstGeom>
-          <a:noFill/>
-          <a:ln/>
-        </p:spPr>
-        <p:txBody>
-          <a:bodyPr wrap="square" lIns="0" tIns="0" rIns="0" bIns="0" rtlCol="0" anchor="ctr"/>
-          <a:lstStyle/>
-          <a:p>
-            <a:pPr algn="ctr" indent="0" marL="0">
-              <a:buNone/>
-            </a:pPr>
-            <a:r>
-              <a:rPr lang="en-US" sz="3600" b="1" dirty="0">
-                <a:solidFill>
-                  <a:schemeClr val="bg1"/>
-                </a:solidFill>
-              </a:rPr>
-              <a:t>EH</a:t>
-            </a:r>
-            <a:endParaRPr lang="en-US" sz="3600" dirty="0"/>
-          </a:p>
-        </p:txBody>
-      </p:sp>
-      <p:sp>
-        <p:nvSpPr>
-          <p:cNvPr id="7" name="Text 5"/>
-          <p:cNvSpPr txBox="1"/>
-          <p:nvPr/>
-        </p:nvSpPr>
-        <p:spPr>
-          <a:xfrm>
-            <a:off x="914400" y="3931920"/>
-            <a:ext cx="4114800" cy="457200"/>
-          </a:xfrm>
-          <a:prstGeom prst="rect">
-            <a:avLst/>
-          </a:prstGeom>
-          <a:noFill/>
-          <a:ln/>
-        </p:spPr>
-        <p:txBody>
-          <a:bodyPr wrap="square" lIns="0" tIns="0" rIns="0" bIns="0" rtlCol="0" anchor="ctr"/>
-          <a:lstStyle/>
-          <a:p>
-            <a:pPr indent="0" marL="0">
-              <a:buNone/>
-            </a:pPr>
-            <a:r>
-              <a:rPr lang="en-US" sz="2400" b="1" dirty="0">
-                <a:solidFill>
-                  <a:schemeClr val="tx1"/>
-                </a:solidFill>
-              </a:rPr>
-              <a:t>Elias Hauck</a:t>
-            </a:r>
-            <a:endParaRPr lang="en-US" sz="2400" dirty="0"/>
-          </a:p>
-        </p:txBody>
-      </p:sp>
-      <p:sp>
-        <p:nvSpPr>
-          <p:cNvPr id="8" name="Text 6"/>
-          <p:cNvSpPr txBox="1"/>
-          <p:nvPr/>
-        </p:nvSpPr>
-        <p:spPr>
-          <a:xfrm>
-            <a:off x="914400" y="4434840"/>
-            <a:ext cx="4114800" cy="731520"/>
-          </a:xfrm>
-          <a:prstGeom prst="rect">
-            <a:avLst/>
-          </a:prstGeom>
-          <a:noFill/>
-          <a:ln/>
-        </p:spPr>
-        <p:txBody>
-          <a:bodyPr wrap="square" lIns="0" tIns="0" rIns="0" bIns="0" rtlCol="0" anchor="ctr"/>
-          <a:lstStyle/>
-          <a:p>
-            <a:pPr indent="0" marL="0">
-              <a:buNone/>
-            </a:pPr>
-            <a:r>
-              <a:rPr lang="en-US" sz="1500" dirty="0">
-                <a:solidFill>
-                  <a:schemeClr val="tx2"/>
-                </a:solidFill>
-              </a:rPr>
-              <a:t>Geschäftsführer und Gründer</a:t>
-            </a:r>
-            <a:endParaRPr lang="en-US" sz="1500" dirty="0"/>
-          </a:p>
-          <a:p>
-            <a:pPr indent="0" marL="0">
-              <a:buNone/>
-            </a:pPr>
-            <a:r>
-              <a:rPr lang="en-US" sz="1500" dirty="0">
-                <a:solidFill>
-                  <a:schemeClr val="tx2"/>
-                </a:solidFill>
-              </a:rPr>
-              <a:t>asuno und SH&amp;Partner</a:t>
-            </a:r>
-            <a:endParaRPr lang="en-US" sz="1500" dirty="0"/>
-          </a:p>
-        </p:txBody>
-      </p:sp>
-      <p:sp>
-        <p:nvSpPr>
-          <p:cNvPr id="9" name="Karte Umfrage"/>
-          <p:cNvSpPr/>
-          <p:nvPr/>
-        </p:nvSpPr>
-        <p:spPr>
-          <a:xfrm>
-            <a:off x="5760720" y="1828800"/>
-            <a:ext cx="5879592" cy="3749040"/>
-          </a:xfrm>
-          <a:prstGeom prst="roundRect">
-            <a:avLst>
-              <a:gd name="adj" fmla="val 1951"/>
-            </a:avLst>
-          </a:prstGeom>
-          <a:solidFill>
-            <a:schemeClr val="tx1"/>
-          </a:solidFill>
-          <a:ln/>
-        </p:spPr>
-      </p:sp>
-      <p:sp>
-        <p:nvSpPr>
-          <p:cNvPr id="10" name="Icon-Kreis LuHand"/>
-          <p:cNvSpPr/>
-          <p:nvPr/>
-        </p:nvSpPr>
-        <p:spPr>
-          <a:xfrm>
-            <a:off x="6172200" y="2194560"/>
-            <a:ext cx="685800" cy="685800"/>
-          </a:xfrm>
-          <a:prstGeom prst="ellipse">
-            <a:avLst/>
-          </a:prstGeom>
-          <a:solidFill>
-            <a:schemeClr val="accent1"/>
-          </a:solidFill>
-          <a:ln/>
-        </p:spPr>
-      </p:sp>
       <p:pic>
         <p:nvPicPr>
-          <p:cNvPr id="11" name="Icon LuHand" descr="preencoded.png">    </p:cNvPr>
+          <p:cNvPr id="5" name="Foto Elias Hauck" descr="Foto von Elias Hauck">    </p:cNvPr>
           <p:cNvPicPr>
             <a:picLocks noChangeAspect="1"/>
           </p:cNvPicPr>
@@ -9824,6 +9756,158 @@
         </p:blipFill>
         <p:spPr>
           <a:xfrm>
+            <a:off x="914400" y="2148840"/>
+            <a:ext cx="1600200" cy="1600200"/>
+          </a:xfrm>
+          <a:prstGeom prst="rect">
+            <a:avLst/>
+          </a:prstGeom>
+        </p:spPr>
+      </p:pic>
+      <p:sp>
+        <p:nvSpPr>
+          <p:cNvPr id="6" name="Text 3"/>
+          <p:cNvSpPr txBox="1"/>
+          <p:nvPr/>
+        </p:nvSpPr>
+        <p:spPr>
+          <a:xfrm>
+            <a:off x="914400" y="3931920"/>
+            <a:ext cx="4114800" cy="457200"/>
+          </a:xfrm>
+          <a:prstGeom prst="rect">
+            <a:avLst/>
+          </a:prstGeom>
+          <a:noFill/>
+          <a:ln/>
+        </p:spPr>
+        <p:txBody>
+          <a:bodyPr wrap="square" lIns="0" tIns="0" rIns="0" bIns="0" rtlCol="0" anchor="ctr"/>
+          <a:lstStyle/>
+          <a:p>
+            <a:pPr indent="0" marL="0">
+              <a:buNone/>
+            </a:pPr>
+            <a:r>
+              <a:rPr lang="en-US" sz="2400" b="1" dirty="0">
+                <a:solidFill>
+                  <a:schemeClr val="tx1"/>
+                </a:solidFill>
+              </a:rPr>
+              <a:t>Elias Hauck</a:t>
+            </a:r>
+            <a:endParaRPr lang="en-US" sz="2400" dirty="0"/>
+          </a:p>
+        </p:txBody>
+      </p:sp>
+      <p:sp>
+        <p:nvSpPr>
+          <p:cNvPr id="7" name="Text 4"/>
+          <p:cNvSpPr txBox="1"/>
+          <p:nvPr/>
+        </p:nvSpPr>
+        <p:spPr>
+          <a:xfrm>
+            <a:off x="914400" y="4434840"/>
+            <a:ext cx="4114800" cy="731520"/>
+          </a:xfrm>
+          <a:prstGeom prst="rect">
+            <a:avLst/>
+          </a:prstGeom>
+          <a:noFill/>
+          <a:ln/>
+        </p:spPr>
+        <p:txBody>
+          <a:bodyPr wrap="square" lIns="0" tIns="0" rIns="0" bIns="0" rtlCol="0" anchor="ctr"/>
+          <a:lstStyle/>
+          <a:p>
+            <a:pPr indent="0" marL="0">
+              <a:buNone/>
+            </a:pPr>
+            <a:r>
+              <a:rPr lang="en-US" sz="1500" dirty="0">
+                <a:solidFill>
+                  <a:schemeClr val="tx2"/>
+                </a:solidFill>
+              </a:rPr>
+              <a:t>Geschäftsführer und Gründer</a:t>
+            </a:r>
+            <a:endParaRPr lang="en-US" sz="1500" dirty="0"/>
+          </a:p>
+          <a:p>
+            <a:pPr indent="0" marL="0">
+              <a:buNone/>
+            </a:pPr>
+            <a:r>
+              <a:rPr lang="en-US" sz="1500" dirty="0">
+                <a:solidFill>
+                  <a:schemeClr val="tx2"/>
+                </a:solidFill>
+              </a:rPr>
+              <a:t>asuno und SH&amp;Partner</a:t>
+            </a:r>
+            <a:endParaRPr lang="en-US" sz="1500" dirty="0"/>
+          </a:p>
+        </p:txBody>
+      </p:sp>
+      <p:sp>
+        <p:nvSpPr>
+          <p:cNvPr id="8" name="Karte Umfrage"/>
+          <p:cNvSpPr/>
+          <p:nvPr/>
+        </p:nvSpPr>
+        <p:spPr>
+          <a:xfrm>
+            <a:off x="5760720" y="1828800"/>
+            <a:ext cx="5879592" cy="3749040"/>
+          </a:xfrm>
+          <a:prstGeom prst="roundRect">
+            <a:avLst>
+              <a:gd name="adj" fmla="val 1951"/>
+            </a:avLst>
+          </a:prstGeom>
+          <a:solidFill>
+            <a:schemeClr val="tx1"/>
+          </a:solidFill>
+          <a:ln/>
+        </p:spPr>
+      </p:sp>
+      <p:sp>
+        <p:nvSpPr>
+          <p:cNvPr id="9" name="Icon-Kreis LuSmartphone"/>
+          <p:cNvSpPr/>
+          <p:nvPr/>
+        </p:nvSpPr>
+        <p:spPr>
+          <a:xfrm>
+            <a:off x="6172200" y="2194560"/>
+            <a:ext cx="685800" cy="685800"/>
+          </a:xfrm>
+          <a:prstGeom prst="ellipse">
+            <a:avLst/>
+          </a:prstGeom>
+          <a:solidFill>
+            <a:schemeClr val="accent1"/>
+          </a:solidFill>
+          <a:ln/>
+        </p:spPr>
+      </p:sp>
+      <p:pic>
+        <p:nvPicPr>
+          <p:cNvPr id="10" name="Icon LuSmartphone" descr="preencoded.png">    </p:cNvPr>
+          <p:cNvPicPr>
+            <a:picLocks noChangeAspect="1"/>
+          </p:cNvPicPr>
+          <p:nvPr/>
+        </p:nvPicPr>
+        <p:blipFill>
+          <a:blip r:embed="rId2"/>
+          <a:stretch>
+            <a:fillRect/>
+          </a:stretch>
+        </p:blipFill>
+        <p:spPr>
+          <a:xfrm>
             <a:off x="6343650" y="2366010"/>
             <a:ext cx="342900" cy="342900"/>
           </a:xfrm>
@@ -9834,7 +9918,7 @@
       </p:pic>
       <p:sp>
         <p:nvSpPr>
-          <p:cNvPr id="12" name="Text 9"/>
+          <p:cNvPr id="11" name="Text 7"/>
           <p:cNvSpPr txBox="1"/>
           <p:nvPr/>
         </p:nvSpPr>
@@ -9862,7 +9946,7 @@
                   <a:schemeClr val="bg1"/>
                 </a:solidFill>
               </a:rPr>
-              <a:t>Hand hoch, wenn …</a:t>
+              <a:t>Macht mit – per Handy!</a:t>
             </a:r>
             <a:endParaRPr lang="en-US" sz="2200" dirty="0"/>
           </a:p>
@@ -9870,7 +9954,7 @@
       </p:sp>
       <p:sp>
         <p:nvSpPr>
-          <p:cNvPr id="13" name="Nummer 1"/>
+          <p:cNvPr id="12" name="Nummer 1"/>
           <p:cNvSpPr/>
           <p:nvPr/>
         </p:nvSpPr>
@@ -9890,7 +9974,7 @@
       </p:sp>
       <p:sp>
         <p:nvSpPr>
-          <p:cNvPr id="14" name="Text 11"/>
+          <p:cNvPr id="13" name="Text 9"/>
           <p:cNvSpPr txBox="1"/>
           <p:nvPr/>
         </p:nvSpPr>
@@ -9926,7 +10010,7 @@
       </p:sp>
       <p:sp>
         <p:nvSpPr>
-          <p:cNvPr id="15" name="Text 12"/>
+          <p:cNvPr id="14" name="Text 10"/>
           <p:cNvSpPr txBox="1"/>
           <p:nvPr/>
         </p:nvSpPr>
@@ -9954,7 +10038,7 @@
                   <a:schemeClr val="accent5"/>
                 </a:solidFill>
               </a:rPr>
-              <a:t>… ihr in der letzten Woche eine KI benutzt habt.</a:t>
+              <a:t>menti.com im Browser öffnen</a:t>
             </a:r>
             <a:endParaRPr lang="en-US" sz="1600" dirty="0"/>
           </a:p>
@@ -9962,7 +10046,7 @@
       </p:sp>
       <p:sp>
         <p:nvSpPr>
-          <p:cNvPr id="16" name="Nummer 2"/>
+          <p:cNvPr id="15" name="Nummer 2"/>
           <p:cNvSpPr/>
           <p:nvPr/>
         </p:nvSpPr>
@@ -9982,7 +10066,7 @@
       </p:sp>
       <p:sp>
         <p:nvSpPr>
-          <p:cNvPr id="17" name="Text 14"/>
+          <p:cNvPr id="16" name="Text 12"/>
           <p:cNvSpPr txBox="1"/>
           <p:nvPr/>
         </p:nvSpPr>
@@ -10018,7 +10102,7 @@
       </p:sp>
       <p:sp>
         <p:nvSpPr>
-          <p:cNvPr id="18" name="Text 15"/>
+          <p:cNvPr id="17" name="Text 13"/>
           <p:cNvSpPr txBox="1"/>
           <p:nvPr/>
         </p:nvSpPr>
@@ -10046,7 +10130,7 @@
                   <a:schemeClr val="accent5"/>
                 </a:solidFill>
               </a:rPr>
-              <a:t>… ihr KI schon für die Schule eingesetzt habt.</a:t>
+              <a:t>Code eingeben – er steht gleich oben auf dem Bildschirm</a:t>
             </a:r>
             <a:endParaRPr lang="en-US" sz="1600" dirty="0"/>
           </a:p>
@@ -10054,7 +10138,7 @@
       </p:sp>
       <p:sp>
         <p:nvSpPr>
-          <p:cNvPr id="19" name="Nummer 3"/>
+          <p:cNvPr id="18" name="Nummer 3"/>
           <p:cNvSpPr/>
           <p:nvPr/>
         </p:nvSpPr>
@@ -10074,7 +10158,7 @@
       </p:sp>
       <p:sp>
         <p:nvSpPr>
-          <p:cNvPr id="20" name="Text 17"/>
+          <p:cNvPr id="19" name="Text 15"/>
           <p:cNvSpPr txBox="1"/>
           <p:nvPr/>
         </p:nvSpPr>
@@ -10110,7 +10194,7 @@
       </p:sp>
       <p:sp>
         <p:nvSpPr>
-          <p:cNvPr id="21" name="Text 18"/>
+          <p:cNvPr id="20" name="Text 16"/>
           <p:cNvSpPr txBox="1"/>
           <p:nvPr/>
         </p:nvSpPr>
@@ -10138,9 +10222,67 @@
                   <a:schemeClr val="accent5"/>
                 </a:solidFill>
               </a:rPr>
-              <a:t>… euch eine KI-Antwort schon mal komisch vorkam.</a:t>
+              <a:t>Erste Frage: Woran denkst du bei „KI“?</a:t>
             </a:r>
             <a:endParaRPr lang="en-US" sz="1600" dirty="0"/>
+          </a:p>
+        </p:txBody>
+      </p:sp>
+      <p:sp>
+        <p:nvSpPr>
+          <p:cNvPr id="21" name="Hinweis Menti-Frage 1 + 2"/>
+          <p:cNvSpPr/>
+          <p:nvPr/>
+        </p:nvSpPr>
+        <p:spPr>
+          <a:xfrm>
+            <a:off x="9144000" y="6336792"/>
+            <a:ext cx="1783080" cy="274320"/>
+          </a:xfrm>
+          <a:prstGeom prst="roundRect">
+            <a:avLst>
+              <a:gd name="adj" fmla="val 20000"/>
+            </a:avLst>
+          </a:prstGeom>
+          <a:solidFill>
+            <a:schemeClr val="accent1"/>
+          </a:solidFill>
+          <a:ln/>
+        </p:spPr>
+      </p:sp>
+      <p:sp>
+        <p:nvSpPr>
+          <p:cNvPr id="22" name="Text 18"/>
+          <p:cNvSpPr txBox="1"/>
+          <p:nvPr/>
+        </p:nvSpPr>
+        <p:spPr>
+          <a:xfrm>
+            <a:off x="9144000" y="6336792"/>
+            <a:ext cx="1783080" cy="274320"/>
+          </a:xfrm>
+          <a:prstGeom prst="rect">
+            <a:avLst/>
+          </a:prstGeom>
+          <a:noFill/>
+          <a:ln/>
+        </p:spPr>
+        <p:txBody>
+          <a:bodyPr wrap="square" lIns="0" tIns="0" rIns="0" bIns="0" rtlCol="0" anchor="ctr"/>
+          <a:lstStyle/>
+          <a:p>
+            <a:pPr algn="ctr" indent="0" marL="0">
+              <a:buNone/>
+            </a:pPr>
+            <a:r>
+              <a:rPr lang="en-US" sz="1000" b="1" spc="200" kern="0" dirty="0">
+                <a:solidFill>
+                  <a:schemeClr val="bg1"/>
+                </a:solidFill>
+              </a:rPr>
+              <a:t>MENTI-FRAGE 1 + 2</a:t>
+            </a:r>
+            <a:endParaRPr lang="en-US" sz="1000" dirty="0"/>
           </a:p>
         </p:txBody>
       </p:sp>
@@ -10342,7 +10484,7 @@
                   <a:schemeClr val="accent1"/>
                 </a:solidFill>
               </a:rPr>
-              <a:t>IMPULS · 60 MIN.</a:t>
+              <a:t>IMPULS · CA. 40 MIN.</a:t>
             </a:r>
             <a:endParaRPr lang="en-US" sz="1200" dirty="0"/>
           </a:p>
@@ -12359,6 +12501,64 @@
                 </a:solidFill>
               </a:rPr>
               <a:t>Quelle: Statista, nach Unternehmensangaben. ChatGPT wurde am 30. November 2022 veröffentlicht.</a:t>
+            </a:r>
+            <a:endParaRPr lang="en-US" sz="1000" dirty="0"/>
+          </a:p>
+        </p:txBody>
+      </p:sp>
+      <p:sp>
+        <p:nvSpPr>
+          <p:cNvPr id="22" name="Hinweis Menti-Frage 3"/>
+          <p:cNvSpPr/>
+          <p:nvPr/>
+        </p:nvSpPr>
+        <p:spPr>
+          <a:xfrm>
+            <a:off x="9144000" y="6336792"/>
+            <a:ext cx="1783080" cy="274320"/>
+          </a:xfrm>
+          <a:prstGeom prst="roundRect">
+            <a:avLst>
+              <a:gd name="adj" fmla="val 20000"/>
+            </a:avLst>
+          </a:prstGeom>
+          <a:solidFill>
+            <a:schemeClr val="accent1"/>
+          </a:solidFill>
+          <a:ln/>
+        </p:spPr>
+      </p:sp>
+      <p:sp>
+        <p:nvSpPr>
+          <p:cNvPr id="23" name="Text 21"/>
+          <p:cNvSpPr txBox="1"/>
+          <p:nvPr/>
+        </p:nvSpPr>
+        <p:spPr>
+          <a:xfrm>
+            <a:off x="9144000" y="6336792"/>
+            <a:ext cx="1783080" cy="274320"/>
+          </a:xfrm>
+          <a:prstGeom prst="rect">
+            <a:avLst/>
+          </a:prstGeom>
+          <a:noFill/>
+          <a:ln/>
+        </p:spPr>
+        <p:txBody>
+          <a:bodyPr wrap="square" lIns="0" tIns="0" rIns="0" bIns="0" rtlCol="0" anchor="ctr"/>
+          <a:lstStyle/>
+          <a:p>
+            <a:pPr algn="ctr" indent="0" marL="0">
+              <a:buNone/>
+            </a:pPr>
+            <a:r>
+              <a:rPr lang="en-US" sz="1000" b="1" spc="200" kern="0" dirty="0">
+                <a:solidFill>
+                  <a:schemeClr val="bg1"/>
+                </a:solidFill>
+              </a:rPr>
+              <a:t>MENTI-FRAGE 3</a:t>
             </a:r>
             <a:endParaRPr lang="en-US" sz="1000" dirty="0"/>
           </a:p>

</xml_diff>

<commit_message>
KI-Tag: plan workshop as 3 rotating theme rooms
Adapt to about 70 students per run and 3 supervised groups: the five
stations run in three 45-minute theme rooms, with the teacher guide,
worksheet timings and the keynote's agenda slides updated to match.

Co-Authored-By: Claude Opus 5.5 <noreply@anthropic.com>
Claude-Session: https://claude.ai/code/session_01H9eHZaZTrpoTKHBqh2YYjW
</commit_message>
<xml_diff>
--- a/ki-tag-gymnasium-sued/KI-Tag_Gymnasium-Sued_Impulsvortrag.pptx
+++ b/ki-tag-gymnasium-sued/KI-Tag_Gymnasium-Sued_Impulsvortrag.pptx
@@ -132,7 +132,7 @@
   <p:extLst>
     <p:ext uri="{521415D9-36F7-43E2-AB2F-B90AF26B5E84}">
       <p14:sectionLst xmlns:p14="http://schemas.microsoft.com/office/powerpoint/2010/main">
-        <p14:section name="Einstieg" id="{2183e841-72bb-e5fb-76ff-a40a7451e8bd}">
+        <p14:section name="Einstieg" id="{53cdd3b0-32e9-0f23-0f20-f6ee48dee400}">
           <p14:sldIdLst>
             <p14:sldId id="256"/>
             <p14:sldId id="257"/>
@@ -141,7 +141,7 @@
             <p14:sldId id="260"/>
           </p14:sldIdLst>
         </p14:section>
-        <p14:section name="Staunen" id="{aa02cff7-cd8d-fff1-c912-60e7e7fb775c}">
+        <p14:section name="Staunen" id="{8a2f8613-42c9-9d8b-bda1-209012ad4dad}">
           <p14:sldIdLst>
             <p14:sldId id="261"/>
             <p14:sldId id="262"/>
@@ -152,7 +152,7 @@
             <p14:sldId id="267"/>
           </p14:sldIdLst>
         </p14:section>
-        <p14:section name="Verstehen" id="{d52209b7-06e1-4bc6-939c-91b935971525}">
+        <p14:section name="Verstehen" id="{2acb20db-50e1-992f-5dc9-43e2bc000ead}">
           <p14:sldIdLst>
             <p14:sldId id="268"/>
             <p14:sldId id="269"/>
@@ -160,14 +160,14 @@
             <p14:sldId id="271"/>
           </p14:sldIdLst>
         </p14:section>
-        <p14:section name="Chancen" id="{c0e6b35a-efc8-1ae2-0759-45d1fc0d2b0c}">
+        <p14:section name="Chancen" id="{7f0f55fa-0f12-e6ab-0d46-12a8c2ae2bad}">
           <p14:sldIdLst>
             <p14:sldId id="272"/>
             <p14:sldId id="273"/>
             <p14:sldId id="274"/>
           </p14:sldIdLst>
         </p14:section>
-        <p14:section name="Risiken &amp; Verantwortung" id="{2cacab90-f89c-dddd-2198-289e459a6cb6}">
+        <p14:section name="Risiken &amp; Verantwortung" id="{2f34c55c-e1e6-dcd4-e126-30443d2a9c82}">
           <p14:sldIdLst>
             <p14:sldId id="275"/>
             <p14:sldId id="276"/>
@@ -176,7 +176,7 @@
             <p14:sldId id="279"/>
           </p14:sldIdLst>
         </p14:section>
-        <p14:section name="Mission" id="{dd76fb59-517d-de0c-8a1b-cc43849cbd3f}">
+        <p14:section name="Mission" id="{5b4a9187-c6fa-ff1d-80f3-98f0586826b9}">
           <p14:sldIdLst>
             <p14:sldId id="280"/>
             <p14:sldId id="281"/>
@@ -2317,7 +2317,7 @@
           <a:p>
             <a:r>
               <a:rPr lang="en-US" dirty="0"/>
-              <a:t>Ca. 1,5 Min. Stationen kurz vorstellen, Gruppeneinteilung und Rotation erklären (wer startet wo, Signal zum Wechseln, Pause). Alles, was ihr gerade in den Challenges erlebt habt, vertieft ihr jetzt selbst.</a:t>
+              <a:t>Ca. 1,5 Min. Stationen kurz vorstellen. In Raum 1 und 2 teilt sich die Gruppe in zwei Hälften, die nach 20 Minuten die Station tauschen; in Raum 3 arbeitet die ganze Gruppe. Rotation: Gruppe A startet in Raum 1, B in Raum 2, C in Raum 3. Alles, was ihr gerade in den Challenges erlebt habt, vertieft ihr jetzt selbst.</a:t>
             </a:r>
             <a:endParaRPr lang="en-US" dirty="0"/>
           </a:p>
@@ -2669,7 +2669,7 @@
           <a:p>
             <a:r>
               <a:rPr lang="en-US" dirty="0"/>
-              <a:t>Ca. 1 Min. Ablauf erklären: Impuls mit Challenges in vier Teilen, dann Workshop-Parcours in 5 Gruppen à ca. 11 Personen.</a:t>
+              <a:t>Ca. 1 Min. Ablauf erklären: Impuls mit Challenges in vier Teilen. Danach teilt ihr euch in 3 Gruppen à ca. 23 und durchlauft nacheinander alle drei Themenräume à 45 Minuten – so macht jede und jeder alle 5 Stationen. Gruppeneinteilung und Startraum hier ansagen.</a:t>
             </a:r>
             <a:endParaRPr lang="en-US" dirty="0"/>
           </a:p>
@@ -14162,7 +14162,7 @@
                   <a:schemeClr val="tx2"/>
                 </a:solidFill>
               </a:rPr>
-              <a:t>5 Stationen · 5 Gruppen à ca. 11 Personen · ca. 25 Minuten pro Station</a:t>
+              <a:t>3 Gruppen · 3 Themenräume à 45 Minuten · alle 5 Stationen</a:t>
             </a:r>
             <a:endParaRPr lang="en-US" sz="1500" dirty="0"/>
           </a:p>
@@ -14170,14 +14170,188 @@
       </p:sp>
       <p:sp>
         <p:nvSpPr>
-          <p:cNvPr id="4" name="Station 1"/>
+          <p:cNvPr id="4" name="RAUM 1 · KI NUTZEN"/>
           <p:cNvSpPr/>
           <p:nvPr/>
         </p:nvSpPr>
         <p:spPr>
           <a:xfrm>
-            <a:off x="484632" y="2103120"/>
-            <a:ext cx="2103120" cy="3931920"/>
+            <a:off x="484632" y="2057400"/>
+            <a:ext cx="4379976" cy="329184"/>
+          </a:xfrm>
+          <a:prstGeom prst="roundRect">
+            <a:avLst>
+              <a:gd name="adj" fmla="val 50000"/>
+            </a:avLst>
+          </a:prstGeom>
+          <a:solidFill>
+            <a:schemeClr val="accent5"/>
+          </a:solidFill>
+          <a:ln/>
+        </p:spPr>
+      </p:sp>
+      <p:sp>
+        <p:nvSpPr>
+          <p:cNvPr id="5" name="Text 3"/>
+          <p:cNvSpPr txBox="1"/>
+          <p:nvPr/>
+        </p:nvSpPr>
+        <p:spPr>
+          <a:xfrm>
+            <a:off x="484632" y="2057400"/>
+            <a:ext cx="4379976" cy="329184"/>
+          </a:xfrm>
+          <a:prstGeom prst="rect">
+            <a:avLst/>
+          </a:prstGeom>
+          <a:noFill/>
+          <a:ln/>
+        </p:spPr>
+        <p:txBody>
+          <a:bodyPr wrap="square" lIns="0" tIns="0" rIns="0" bIns="0" rtlCol="0" anchor="ctr"/>
+          <a:lstStyle/>
+          <a:p>
+            <a:pPr algn="ctr" indent="0" marL="0">
+              <a:buNone/>
+            </a:pPr>
+            <a:r>
+              <a:rPr lang="en-US" sz="900" b="1" spc="100" kern="0" dirty="0">
+                <a:solidFill>
+                  <a:schemeClr val="accent1"/>
+                </a:solidFill>
+              </a:rPr>
+              <a:t>RAUM 1 · KI NUTZEN</a:t>
+            </a:r>
+            <a:endParaRPr lang="en-US" sz="900" dirty="0"/>
+          </a:p>
+        </p:txBody>
+      </p:sp>
+      <p:sp>
+        <p:nvSpPr>
+          <p:cNvPr id="6" name="RAUM 2 · KI PRÜFEN"/>
+          <p:cNvSpPr/>
+          <p:nvPr/>
+        </p:nvSpPr>
+        <p:spPr>
+          <a:xfrm>
+            <a:off x="5038344" y="2057400"/>
+            <a:ext cx="4379976" cy="329184"/>
+          </a:xfrm>
+          <a:prstGeom prst="roundRect">
+            <a:avLst>
+              <a:gd name="adj" fmla="val 50000"/>
+            </a:avLst>
+          </a:prstGeom>
+          <a:solidFill>
+            <a:schemeClr val="accent5"/>
+          </a:solidFill>
+          <a:ln/>
+        </p:spPr>
+      </p:sp>
+      <p:sp>
+        <p:nvSpPr>
+          <p:cNvPr id="7" name="Text 5"/>
+          <p:cNvSpPr txBox="1"/>
+          <p:nvPr/>
+        </p:nvSpPr>
+        <p:spPr>
+          <a:xfrm>
+            <a:off x="5038344" y="2057400"/>
+            <a:ext cx="4379976" cy="329184"/>
+          </a:xfrm>
+          <a:prstGeom prst="rect">
+            <a:avLst/>
+          </a:prstGeom>
+          <a:noFill/>
+          <a:ln/>
+        </p:spPr>
+        <p:txBody>
+          <a:bodyPr wrap="square" lIns="0" tIns="0" rIns="0" bIns="0" rtlCol="0" anchor="ctr"/>
+          <a:lstStyle/>
+          <a:p>
+            <a:pPr algn="ctr" indent="0" marL="0">
+              <a:buNone/>
+            </a:pPr>
+            <a:r>
+              <a:rPr lang="en-US" sz="900" b="1" spc="100" kern="0" dirty="0">
+                <a:solidFill>
+                  <a:schemeClr val="accent1"/>
+                </a:solidFill>
+              </a:rPr>
+              <a:t>RAUM 2 · KI PRÜFEN</a:t>
+            </a:r>
+            <a:endParaRPr lang="en-US" sz="900" dirty="0"/>
+          </a:p>
+        </p:txBody>
+      </p:sp>
+      <p:sp>
+        <p:nvSpPr>
+          <p:cNvPr id="8" name="RAUM 3 · KI GESTALTEN"/>
+          <p:cNvSpPr/>
+          <p:nvPr/>
+        </p:nvSpPr>
+        <p:spPr>
+          <a:xfrm>
+            <a:off x="9592056" y="2057400"/>
+            <a:ext cx="2103120" cy="329184"/>
+          </a:xfrm>
+          <a:prstGeom prst="roundRect">
+            <a:avLst>
+              <a:gd name="adj" fmla="val 50000"/>
+            </a:avLst>
+          </a:prstGeom>
+          <a:solidFill>
+            <a:schemeClr val="accent5"/>
+          </a:solidFill>
+          <a:ln/>
+        </p:spPr>
+      </p:sp>
+      <p:sp>
+        <p:nvSpPr>
+          <p:cNvPr id="9" name="Text 7"/>
+          <p:cNvSpPr txBox="1"/>
+          <p:nvPr/>
+        </p:nvSpPr>
+        <p:spPr>
+          <a:xfrm>
+            <a:off x="9592056" y="2057400"/>
+            <a:ext cx="2103120" cy="329184"/>
+          </a:xfrm>
+          <a:prstGeom prst="rect">
+            <a:avLst/>
+          </a:prstGeom>
+          <a:noFill/>
+          <a:ln/>
+        </p:spPr>
+        <p:txBody>
+          <a:bodyPr wrap="square" lIns="0" tIns="0" rIns="0" bIns="0" rtlCol="0" anchor="ctr"/>
+          <a:lstStyle/>
+          <a:p>
+            <a:pPr algn="ctr" indent="0" marL="0">
+              <a:buNone/>
+            </a:pPr>
+            <a:r>
+              <a:rPr lang="en-US" sz="900" b="1" spc="100" kern="0" dirty="0">
+                <a:solidFill>
+                  <a:schemeClr val="accent1"/>
+                </a:solidFill>
+              </a:rPr>
+              <a:t>RAUM 3 · KI GESTALTEN</a:t>
+            </a:r>
+            <a:endParaRPr lang="en-US" sz="900" dirty="0"/>
+          </a:p>
+        </p:txBody>
+      </p:sp>
+      <p:sp>
+        <p:nvSpPr>
+          <p:cNvPr id="10" name="Station 1"/>
+          <p:cNvSpPr/>
+          <p:nvPr/>
+        </p:nvSpPr>
+        <p:spPr>
+          <a:xfrm>
+            <a:off x="484632" y="2542032"/>
+            <a:ext cx="2103120" cy="3520440"/>
           </a:xfrm>
           <a:prstGeom prst="roundRect">
             <a:avLst>
@@ -14199,14 +14373,14 @@
       </p:sp>
       <p:sp>
         <p:nvSpPr>
-          <p:cNvPr id="5" name="Text 3"/>
-          <p:cNvSpPr txBox="1"/>
-          <p:nvPr/>
-        </p:nvSpPr>
-        <p:spPr>
-          <a:xfrm>
-            <a:off x="685800" y="2240280"/>
-            <a:ext cx="1097280" cy="640080"/>
+          <p:cNvPr id="11" name="Text 9"/>
+          <p:cNvSpPr txBox="1"/>
+          <p:nvPr/>
+        </p:nvSpPr>
+        <p:spPr>
+          <a:xfrm>
+            <a:off x="685800" y="2633472"/>
+            <a:ext cx="1097280" cy="566928"/>
           </a:xfrm>
           <a:prstGeom prst="rect">
             <a:avLst/>
@@ -14222,27 +14396,27 @@
               <a:buNone/>
             </a:pPr>
             <a:r>
-              <a:rPr lang="en-US" sz="3000" b="1" dirty="0">
+              <a:rPr lang="en-US" sz="2800" b="1" dirty="0">
                 <a:solidFill>
                   <a:schemeClr val="accent1"/>
                 </a:solidFill>
               </a:rPr>
               <a:t>01</a:t>
             </a:r>
-            <a:endParaRPr lang="en-US" sz="3000" dirty="0"/>
-          </a:p>
-        </p:txBody>
-      </p:sp>
-      <p:sp>
-        <p:nvSpPr>
-          <p:cNvPr id="6" name="Text 4"/>
-          <p:cNvSpPr txBox="1"/>
-          <p:nvPr/>
-        </p:nvSpPr>
-        <p:spPr>
-          <a:xfrm>
-            <a:off x="685800" y="2880360"/>
-            <a:ext cx="1737360" cy="640080"/>
+            <a:endParaRPr lang="en-US" sz="2800" dirty="0"/>
+          </a:p>
+        </p:txBody>
+      </p:sp>
+      <p:sp>
+        <p:nvSpPr>
+          <p:cNvPr id="12" name="Text 10"/>
+          <p:cNvSpPr txBox="1"/>
+          <p:nvPr/>
+        </p:nvSpPr>
+        <p:spPr>
+          <a:xfrm>
+            <a:off x="685800" y="3200400"/>
+            <a:ext cx="1737360" cy="621792"/>
           </a:xfrm>
           <a:prstGeom prst="rect">
             <a:avLst/>
@@ -14271,14 +14445,14 @@
       </p:sp>
       <p:sp>
         <p:nvSpPr>
-          <p:cNvPr id="7" name="Text 5"/>
-          <p:cNvSpPr txBox="1"/>
-          <p:nvPr/>
-        </p:nvSpPr>
-        <p:spPr>
-          <a:xfrm>
-            <a:off x="685800" y="3520440"/>
-            <a:ext cx="1737360" cy="1325880"/>
+          <p:cNvPr id="13" name="Text 11"/>
+          <p:cNvSpPr txBox="1"/>
+          <p:nvPr/>
+        </p:nvSpPr>
+        <p:spPr>
+          <a:xfrm>
+            <a:off x="685800" y="3822192"/>
+            <a:ext cx="1737360" cy="1188720"/>
           </a:xfrm>
           <a:prstGeom prst="rect">
             <a:avLst/>
@@ -14307,14 +14481,14 @@
       </p:sp>
       <p:sp>
         <p:nvSpPr>
-          <p:cNvPr id="8" name="Text 6"/>
-          <p:cNvSpPr txBox="1"/>
-          <p:nvPr/>
-        </p:nvSpPr>
-        <p:spPr>
-          <a:xfrm>
-            <a:off x="685800" y="4892040"/>
-            <a:ext cx="1737360" cy="1005840"/>
+          <p:cNvPr id="14" name="Text 12"/>
+          <p:cNvSpPr txBox="1"/>
+          <p:nvPr/>
+        </p:nvSpPr>
+        <p:spPr>
+          <a:xfrm>
+            <a:off x="685800" y="5029200"/>
+            <a:ext cx="1737360" cy="960120"/>
           </a:xfrm>
           <a:prstGeom prst="rect">
             <a:avLst/>
@@ -14343,14 +14517,14 @@
       </p:sp>
       <p:sp>
         <p:nvSpPr>
-          <p:cNvPr id="9" name="Station 2"/>
+          <p:cNvPr id="15" name="Station 2"/>
           <p:cNvSpPr/>
           <p:nvPr/>
         </p:nvSpPr>
         <p:spPr>
           <a:xfrm>
-            <a:off x="2761488" y="2103120"/>
-            <a:ext cx="2103120" cy="3931920"/>
+            <a:off x="2761488" y="2542032"/>
+            <a:ext cx="2103120" cy="3520440"/>
           </a:xfrm>
           <a:prstGeom prst="roundRect">
             <a:avLst>
@@ -14372,14 +14546,14 @@
       </p:sp>
       <p:sp>
         <p:nvSpPr>
-          <p:cNvPr id="10" name="Text 8"/>
-          <p:cNvSpPr txBox="1"/>
-          <p:nvPr/>
-        </p:nvSpPr>
-        <p:spPr>
-          <a:xfrm>
-            <a:off x="2962656" y="2240280"/>
-            <a:ext cx="1097280" cy="640080"/>
+          <p:cNvPr id="16" name="Text 14"/>
+          <p:cNvSpPr txBox="1"/>
+          <p:nvPr/>
+        </p:nvSpPr>
+        <p:spPr>
+          <a:xfrm>
+            <a:off x="2962656" y="2633472"/>
+            <a:ext cx="1097280" cy="566928"/>
           </a:xfrm>
           <a:prstGeom prst="rect">
             <a:avLst/>
@@ -14395,27 +14569,27 @@
               <a:buNone/>
             </a:pPr>
             <a:r>
-              <a:rPr lang="en-US" sz="3000" b="1" dirty="0">
+              <a:rPr lang="en-US" sz="2800" b="1" dirty="0">
                 <a:solidFill>
                   <a:schemeClr val="accent1"/>
                 </a:solidFill>
               </a:rPr>
               <a:t>02</a:t>
             </a:r>
-            <a:endParaRPr lang="en-US" sz="3000" dirty="0"/>
-          </a:p>
-        </p:txBody>
-      </p:sp>
-      <p:sp>
-        <p:nvSpPr>
-          <p:cNvPr id="11" name="Text 9"/>
-          <p:cNvSpPr txBox="1"/>
-          <p:nvPr/>
-        </p:nvSpPr>
-        <p:spPr>
-          <a:xfrm>
-            <a:off x="2962656" y="2880360"/>
-            <a:ext cx="1737360" cy="640080"/>
+            <a:endParaRPr lang="en-US" sz="2800" dirty="0"/>
+          </a:p>
+        </p:txBody>
+      </p:sp>
+      <p:sp>
+        <p:nvSpPr>
+          <p:cNvPr id="17" name="Text 15"/>
+          <p:cNvSpPr txBox="1"/>
+          <p:nvPr/>
+        </p:nvSpPr>
+        <p:spPr>
+          <a:xfrm>
+            <a:off x="2962656" y="3200400"/>
+            <a:ext cx="1737360" cy="621792"/>
           </a:xfrm>
           <a:prstGeom prst="rect">
             <a:avLst/>
@@ -14444,14 +14618,14 @@
       </p:sp>
       <p:sp>
         <p:nvSpPr>
-          <p:cNvPr id="12" name="Text 10"/>
-          <p:cNvSpPr txBox="1"/>
-          <p:nvPr/>
-        </p:nvSpPr>
-        <p:spPr>
-          <a:xfrm>
-            <a:off x="2962656" y="3520440"/>
-            <a:ext cx="1737360" cy="1325880"/>
+          <p:cNvPr id="18" name="Text 16"/>
+          <p:cNvSpPr txBox="1"/>
+          <p:nvPr/>
+        </p:nvSpPr>
+        <p:spPr>
+          <a:xfrm>
+            <a:off x="2962656" y="3822192"/>
+            <a:ext cx="1737360" cy="1188720"/>
           </a:xfrm>
           <a:prstGeom prst="rect">
             <a:avLst/>
@@ -14480,14 +14654,14 @@
       </p:sp>
       <p:sp>
         <p:nvSpPr>
-          <p:cNvPr id="13" name="Text 11"/>
-          <p:cNvSpPr txBox="1"/>
-          <p:nvPr/>
-        </p:nvSpPr>
-        <p:spPr>
-          <a:xfrm>
-            <a:off x="2962656" y="4892040"/>
-            <a:ext cx="1737360" cy="1005840"/>
+          <p:cNvPr id="19" name="Text 17"/>
+          <p:cNvSpPr txBox="1"/>
+          <p:nvPr/>
+        </p:nvSpPr>
+        <p:spPr>
+          <a:xfrm>
+            <a:off x="2962656" y="5029200"/>
+            <a:ext cx="1737360" cy="960120"/>
           </a:xfrm>
           <a:prstGeom prst="rect">
             <a:avLst/>
@@ -14516,14 +14690,14 @@
       </p:sp>
       <p:sp>
         <p:nvSpPr>
-          <p:cNvPr id="14" name="Station 3"/>
+          <p:cNvPr id="20" name="Station 3"/>
           <p:cNvSpPr/>
           <p:nvPr/>
         </p:nvSpPr>
         <p:spPr>
           <a:xfrm>
-            <a:off x="5038344" y="2103120"/>
-            <a:ext cx="2103120" cy="3931920"/>
+            <a:off x="5038344" y="2542032"/>
+            <a:ext cx="2103120" cy="3520440"/>
           </a:xfrm>
           <a:prstGeom prst="roundRect">
             <a:avLst>
@@ -14545,14 +14719,14 @@
       </p:sp>
       <p:sp>
         <p:nvSpPr>
-          <p:cNvPr id="15" name="Text 13"/>
-          <p:cNvSpPr txBox="1"/>
-          <p:nvPr/>
-        </p:nvSpPr>
-        <p:spPr>
-          <a:xfrm>
-            <a:off x="5239512" y="2240280"/>
-            <a:ext cx="1097280" cy="640080"/>
+          <p:cNvPr id="21" name="Text 19"/>
+          <p:cNvSpPr txBox="1"/>
+          <p:nvPr/>
+        </p:nvSpPr>
+        <p:spPr>
+          <a:xfrm>
+            <a:off x="5239512" y="2633472"/>
+            <a:ext cx="1097280" cy="566928"/>
           </a:xfrm>
           <a:prstGeom prst="rect">
             <a:avLst/>
@@ -14568,27 +14742,27 @@
               <a:buNone/>
             </a:pPr>
             <a:r>
-              <a:rPr lang="en-US" sz="3000" b="1" dirty="0">
+              <a:rPr lang="en-US" sz="2800" b="1" dirty="0">
                 <a:solidFill>
                   <a:schemeClr val="accent1"/>
                 </a:solidFill>
               </a:rPr>
               <a:t>03</a:t>
             </a:r>
-            <a:endParaRPr lang="en-US" sz="3000" dirty="0"/>
-          </a:p>
-        </p:txBody>
-      </p:sp>
-      <p:sp>
-        <p:nvSpPr>
-          <p:cNvPr id="16" name="Text 14"/>
-          <p:cNvSpPr txBox="1"/>
-          <p:nvPr/>
-        </p:nvSpPr>
-        <p:spPr>
-          <a:xfrm>
-            <a:off x="5239512" y="2880360"/>
-            <a:ext cx="1737360" cy="640080"/>
+            <a:endParaRPr lang="en-US" sz="2800" dirty="0"/>
+          </a:p>
+        </p:txBody>
+      </p:sp>
+      <p:sp>
+        <p:nvSpPr>
+          <p:cNvPr id="22" name="Text 20"/>
+          <p:cNvSpPr txBox="1"/>
+          <p:nvPr/>
+        </p:nvSpPr>
+        <p:spPr>
+          <a:xfrm>
+            <a:off x="5239512" y="3200400"/>
+            <a:ext cx="1737360" cy="621792"/>
           </a:xfrm>
           <a:prstGeom prst="rect">
             <a:avLst/>
@@ -14617,14 +14791,14 @@
       </p:sp>
       <p:sp>
         <p:nvSpPr>
-          <p:cNvPr id="17" name="Text 15"/>
-          <p:cNvSpPr txBox="1"/>
-          <p:nvPr/>
-        </p:nvSpPr>
-        <p:spPr>
-          <a:xfrm>
-            <a:off x="5239512" y="3520440"/>
-            <a:ext cx="1737360" cy="1325880"/>
+          <p:cNvPr id="23" name="Text 21"/>
+          <p:cNvSpPr txBox="1"/>
+          <p:nvPr/>
+        </p:nvSpPr>
+        <p:spPr>
+          <a:xfrm>
+            <a:off x="5239512" y="3822192"/>
+            <a:ext cx="1737360" cy="1188720"/>
           </a:xfrm>
           <a:prstGeom prst="rect">
             <a:avLst/>
@@ -14653,14 +14827,14 @@
       </p:sp>
       <p:sp>
         <p:nvSpPr>
-          <p:cNvPr id="18" name="Text 16"/>
-          <p:cNvSpPr txBox="1"/>
-          <p:nvPr/>
-        </p:nvSpPr>
-        <p:spPr>
-          <a:xfrm>
-            <a:off x="5239512" y="4892040"/>
-            <a:ext cx="1737360" cy="1005840"/>
+          <p:cNvPr id="24" name="Text 22"/>
+          <p:cNvSpPr txBox="1"/>
+          <p:nvPr/>
+        </p:nvSpPr>
+        <p:spPr>
+          <a:xfrm>
+            <a:off x="5239512" y="5029200"/>
+            <a:ext cx="1737360" cy="960120"/>
           </a:xfrm>
           <a:prstGeom prst="rect">
             <a:avLst/>
@@ -14689,14 +14863,14 @@
       </p:sp>
       <p:sp>
         <p:nvSpPr>
-          <p:cNvPr id="19" name="Station 4"/>
+          <p:cNvPr id="25" name="Station 4"/>
           <p:cNvSpPr/>
           <p:nvPr/>
         </p:nvSpPr>
         <p:spPr>
           <a:xfrm>
-            <a:off x="7315200" y="2103120"/>
-            <a:ext cx="2103120" cy="3931920"/>
+            <a:off x="7315200" y="2542032"/>
+            <a:ext cx="2103120" cy="3520440"/>
           </a:xfrm>
           <a:prstGeom prst="roundRect">
             <a:avLst>
@@ -14718,14 +14892,14 @@
       </p:sp>
       <p:sp>
         <p:nvSpPr>
-          <p:cNvPr id="20" name="Text 18"/>
-          <p:cNvSpPr txBox="1"/>
-          <p:nvPr/>
-        </p:nvSpPr>
-        <p:spPr>
-          <a:xfrm>
-            <a:off x="7516368" y="2240280"/>
-            <a:ext cx="1097280" cy="640080"/>
+          <p:cNvPr id="26" name="Text 24"/>
+          <p:cNvSpPr txBox="1"/>
+          <p:nvPr/>
+        </p:nvSpPr>
+        <p:spPr>
+          <a:xfrm>
+            <a:off x="7516368" y="2633472"/>
+            <a:ext cx="1097280" cy="566928"/>
           </a:xfrm>
           <a:prstGeom prst="rect">
             <a:avLst/>
@@ -14741,27 +14915,27 @@
               <a:buNone/>
             </a:pPr>
             <a:r>
-              <a:rPr lang="en-US" sz="3000" b="1" dirty="0">
+              <a:rPr lang="en-US" sz="2800" b="1" dirty="0">
                 <a:solidFill>
                   <a:schemeClr val="accent1"/>
                 </a:solidFill>
               </a:rPr>
               <a:t>04</a:t>
             </a:r>
-            <a:endParaRPr lang="en-US" sz="3000" dirty="0"/>
-          </a:p>
-        </p:txBody>
-      </p:sp>
-      <p:sp>
-        <p:nvSpPr>
-          <p:cNvPr id="21" name="Text 19"/>
-          <p:cNvSpPr txBox="1"/>
-          <p:nvPr/>
-        </p:nvSpPr>
-        <p:spPr>
-          <a:xfrm>
-            <a:off x="7516368" y="2880360"/>
-            <a:ext cx="1737360" cy="640080"/>
+            <a:endParaRPr lang="en-US" sz="2800" dirty="0"/>
+          </a:p>
+        </p:txBody>
+      </p:sp>
+      <p:sp>
+        <p:nvSpPr>
+          <p:cNvPr id="27" name="Text 25"/>
+          <p:cNvSpPr txBox="1"/>
+          <p:nvPr/>
+        </p:nvSpPr>
+        <p:spPr>
+          <a:xfrm>
+            <a:off x="7516368" y="3200400"/>
+            <a:ext cx="1737360" cy="621792"/>
           </a:xfrm>
           <a:prstGeom prst="rect">
             <a:avLst/>
@@ -14790,14 +14964,14 @@
       </p:sp>
       <p:sp>
         <p:nvSpPr>
-          <p:cNvPr id="22" name="Text 20"/>
-          <p:cNvSpPr txBox="1"/>
-          <p:nvPr/>
-        </p:nvSpPr>
-        <p:spPr>
-          <a:xfrm>
-            <a:off x="7516368" y="3520440"/>
-            <a:ext cx="1737360" cy="1325880"/>
+          <p:cNvPr id="28" name="Text 26"/>
+          <p:cNvSpPr txBox="1"/>
+          <p:nvPr/>
+        </p:nvSpPr>
+        <p:spPr>
+          <a:xfrm>
+            <a:off x="7516368" y="3822192"/>
+            <a:ext cx="1737360" cy="1188720"/>
           </a:xfrm>
           <a:prstGeom prst="rect">
             <a:avLst/>
@@ -14826,14 +15000,14 @@
       </p:sp>
       <p:sp>
         <p:nvSpPr>
-          <p:cNvPr id="23" name="Text 21"/>
-          <p:cNvSpPr txBox="1"/>
-          <p:nvPr/>
-        </p:nvSpPr>
-        <p:spPr>
-          <a:xfrm>
-            <a:off x="7516368" y="4892040"/>
-            <a:ext cx="1737360" cy="1005840"/>
+          <p:cNvPr id="29" name="Text 27"/>
+          <p:cNvSpPr txBox="1"/>
+          <p:nvPr/>
+        </p:nvSpPr>
+        <p:spPr>
+          <a:xfrm>
+            <a:off x="7516368" y="5029200"/>
+            <a:ext cx="1737360" cy="960120"/>
           </a:xfrm>
           <a:prstGeom prst="rect">
             <a:avLst/>
@@ -14862,14 +15036,14 @@
       </p:sp>
       <p:sp>
         <p:nvSpPr>
-          <p:cNvPr id="24" name="Station 5"/>
+          <p:cNvPr id="30" name="Station 5"/>
           <p:cNvSpPr/>
           <p:nvPr/>
         </p:nvSpPr>
         <p:spPr>
           <a:xfrm>
-            <a:off x="9592056" y="2103120"/>
-            <a:ext cx="2103120" cy="3931920"/>
+            <a:off x="9592056" y="2542032"/>
+            <a:ext cx="2103120" cy="3520440"/>
           </a:xfrm>
           <a:prstGeom prst="roundRect">
             <a:avLst>
@@ -14891,14 +15065,14 @@
       </p:sp>
       <p:sp>
         <p:nvSpPr>
-          <p:cNvPr id="25" name="Text 23"/>
-          <p:cNvSpPr txBox="1"/>
-          <p:nvPr/>
-        </p:nvSpPr>
-        <p:spPr>
-          <a:xfrm>
-            <a:off x="9793224" y="2240280"/>
-            <a:ext cx="1097280" cy="640080"/>
+          <p:cNvPr id="31" name="Text 29"/>
+          <p:cNvSpPr txBox="1"/>
+          <p:nvPr/>
+        </p:nvSpPr>
+        <p:spPr>
+          <a:xfrm>
+            <a:off x="9793224" y="2633472"/>
+            <a:ext cx="1097280" cy="566928"/>
           </a:xfrm>
           <a:prstGeom prst="rect">
             <a:avLst/>
@@ -14914,27 +15088,27 @@
               <a:buNone/>
             </a:pPr>
             <a:r>
-              <a:rPr lang="en-US" sz="3000" b="1" dirty="0">
+              <a:rPr lang="en-US" sz="2800" b="1" dirty="0">
                 <a:solidFill>
                   <a:schemeClr val="accent1"/>
                 </a:solidFill>
               </a:rPr>
               <a:t>05</a:t>
             </a:r>
-            <a:endParaRPr lang="en-US" sz="3000" dirty="0"/>
-          </a:p>
-        </p:txBody>
-      </p:sp>
-      <p:sp>
-        <p:nvSpPr>
-          <p:cNvPr id="26" name="Text 24"/>
-          <p:cNvSpPr txBox="1"/>
-          <p:nvPr/>
-        </p:nvSpPr>
-        <p:spPr>
-          <a:xfrm>
-            <a:off x="9793224" y="2880360"/>
-            <a:ext cx="1737360" cy="640080"/>
+            <a:endParaRPr lang="en-US" sz="2800" dirty="0"/>
+          </a:p>
+        </p:txBody>
+      </p:sp>
+      <p:sp>
+        <p:nvSpPr>
+          <p:cNvPr id="32" name="Text 30"/>
+          <p:cNvSpPr txBox="1"/>
+          <p:nvPr/>
+        </p:nvSpPr>
+        <p:spPr>
+          <a:xfrm>
+            <a:off x="9793224" y="3200400"/>
+            <a:ext cx="1737360" cy="621792"/>
           </a:xfrm>
           <a:prstGeom prst="rect">
             <a:avLst/>
@@ -14963,14 +15137,14 @@
       </p:sp>
       <p:sp>
         <p:nvSpPr>
-          <p:cNvPr id="27" name="Text 25"/>
-          <p:cNvSpPr txBox="1"/>
-          <p:nvPr/>
-        </p:nvSpPr>
-        <p:spPr>
-          <a:xfrm>
-            <a:off x="9793224" y="3520440"/>
-            <a:ext cx="1737360" cy="1325880"/>
+          <p:cNvPr id="33" name="Text 31"/>
+          <p:cNvSpPr txBox="1"/>
+          <p:nvPr/>
+        </p:nvSpPr>
+        <p:spPr>
+          <a:xfrm>
+            <a:off x="9793224" y="3822192"/>
+            <a:ext cx="1737360" cy="1188720"/>
           </a:xfrm>
           <a:prstGeom prst="rect">
             <a:avLst/>
@@ -14999,14 +15173,14 @@
       </p:sp>
       <p:sp>
         <p:nvSpPr>
-          <p:cNvPr id="28" name="Text 26"/>
-          <p:cNvSpPr txBox="1"/>
-          <p:nvPr/>
-        </p:nvSpPr>
-        <p:spPr>
-          <a:xfrm>
-            <a:off x="9793224" y="4892040"/>
-            <a:ext cx="1737360" cy="1005840"/>
+          <p:cNvPr id="34" name="Text 32"/>
+          <p:cNvSpPr txBox="1"/>
+          <p:nvPr/>
+        </p:nvSpPr>
+        <p:spPr>
+          <a:xfrm>
+            <a:off x="9793224" y="5029200"/>
+            <a:ext cx="1737360" cy="960120"/>
           </a:xfrm>
           <a:prstGeom prst="rect">
             <a:avLst/>
@@ -16804,7 +16978,7 @@
                   <a:schemeClr val="accent2"/>
                 </a:solidFill>
               </a:rPr>
-              <a:t>WORKSHOP-PARCOURS · 5 STATIONEN À CA. 25 MIN. + 20 MIN. PAUSE</a:t>
+              <a:t>WORKSHOP · 3 THEMENRÄUME À 45 MIN. · 20 MIN. PAUSE</a:t>
             </a:r>
             <a:endParaRPr lang="en-US" sz="1200" dirty="0"/>
           </a:p>
@@ -16812,18 +16986,18 @@
       </p:sp>
       <p:sp>
         <p:nvSpPr>
-          <p:cNvPr id="18" name="Station 1"/>
+          <p:cNvPr id="18" name="Raum 1"/>
           <p:cNvSpPr/>
           <p:nvPr/>
         </p:nvSpPr>
         <p:spPr>
           <a:xfrm>
             <a:off x="484632" y="4480560"/>
-            <a:ext cx="2103120" cy="1188720"/>
+            <a:ext cx="3611880" cy="1280160"/>
           </a:xfrm>
           <a:prstGeom prst="roundRect">
             <a:avLst>
-              <a:gd name="adj" fmla="val 9231"/>
+              <a:gd name="adj" fmla="val 8571"/>
             </a:avLst>
           </a:prstGeom>
           <a:solidFill>
@@ -16834,110 +17008,126 @@
       </p:sp>
       <p:sp>
         <p:nvSpPr>
-          <p:cNvPr id="19" name="Nummer 1"/>
+          <p:cNvPr id="19" name="Text 17"/>
+          <p:cNvSpPr txBox="1"/>
+          <p:nvPr/>
+        </p:nvSpPr>
+        <p:spPr>
+          <a:xfrm>
+            <a:off x="758952" y="4590288"/>
+            <a:ext cx="3108960" cy="274320"/>
+          </a:xfrm>
+          <a:prstGeom prst="rect">
+            <a:avLst/>
+          </a:prstGeom>
+          <a:noFill/>
+          <a:ln/>
+        </p:spPr>
+        <p:txBody>
+          <a:bodyPr wrap="square" lIns="0" tIns="0" rIns="0" bIns="0" rtlCol="0" anchor="ctr"/>
+          <a:lstStyle/>
+          <a:p>
+            <a:pPr indent="0" marL="0">
+              <a:buNone/>
+            </a:pPr>
+            <a:r>
+              <a:rPr lang="en-US" sz="1000" b="1" spc="200" kern="0" dirty="0">
+                <a:solidFill>
+                  <a:schemeClr val="accent1"/>
+                </a:solidFill>
+              </a:rPr>
+              <a:t>RAUM 1</a:t>
+            </a:r>
+            <a:endParaRPr lang="en-US" sz="1000" dirty="0"/>
+          </a:p>
+        </p:txBody>
+      </p:sp>
+      <p:sp>
+        <p:nvSpPr>
+          <p:cNvPr id="20" name="Text 18"/>
+          <p:cNvSpPr txBox="1"/>
+          <p:nvPr/>
+        </p:nvSpPr>
+        <p:spPr>
+          <a:xfrm>
+            <a:off x="758952" y="4846320"/>
+            <a:ext cx="3108960" cy="411480"/>
+          </a:xfrm>
+          <a:prstGeom prst="rect">
+            <a:avLst/>
+          </a:prstGeom>
+          <a:noFill/>
+          <a:ln/>
+        </p:spPr>
+        <p:txBody>
+          <a:bodyPr wrap="square" lIns="0" tIns="0" rIns="0" bIns="0" rtlCol="0" anchor="ctr"/>
+          <a:lstStyle/>
+          <a:p>
+            <a:pPr indent="0" marL="0">
+              <a:buNone/>
+            </a:pPr>
+            <a:r>
+              <a:rPr lang="en-US" sz="1800" b="1" dirty="0">
+                <a:solidFill>
+                  <a:schemeClr val="tx1"/>
+                </a:solidFill>
+              </a:rPr>
+              <a:t>KI nutzen</a:t>
+            </a:r>
+            <a:endParaRPr lang="en-US" sz="1800" dirty="0"/>
+          </a:p>
+        </p:txBody>
+      </p:sp>
+      <p:sp>
+        <p:nvSpPr>
+          <p:cNvPr id="21" name="Text 19"/>
+          <p:cNvSpPr txBox="1"/>
+          <p:nvPr/>
+        </p:nvSpPr>
+        <p:spPr>
+          <a:xfrm>
+            <a:off x="758952" y="5285232"/>
+            <a:ext cx="3200400" cy="320040"/>
+          </a:xfrm>
+          <a:prstGeom prst="rect">
+            <a:avLst/>
+          </a:prstGeom>
+          <a:noFill/>
+          <a:ln/>
+        </p:spPr>
+        <p:txBody>
+          <a:bodyPr wrap="square" lIns="0" tIns="0" rIns="0" bIns="0" rtlCol="0" anchor="ctr"/>
+          <a:lstStyle/>
+          <a:p>
+            <a:pPr indent="0" marL="0">
+              <a:buNone/>
+            </a:pPr>
+            <a:r>
+              <a:rPr lang="en-US" sz="1200" dirty="0">
+                <a:solidFill>
+                  <a:schemeClr val="tx2"/>
+                </a:solidFill>
+              </a:rPr>
+              <a:t>Prompt Battle · KI als Lerncoach</a:t>
+            </a:r>
+            <a:endParaRPr lang="en-US" sz="1200" dirty="0"/>
+          </a:p>
+        </p:txBody>
+      </p:sp>
+      <p:sp>
+        <p:nvSpPr>
+          <p:cNvPr id="22" name="Raum 2"/>
           <p:cNvSpPr/>
           <p:nvPr/>
         </p:nvSpPr>
         <p:spPr>
           <a:xfrm>
-            <a:off x="685800" y="4864608"/>
-            <a:ext cx="420624" cy="420624"/>
-          </a:xfrm>
-          <a:prstGeom prst="ellipse">
-            <a:avLst/>
-          </a:prstGeom>
-          <a:solidFill>
-            <a:schemeClr val="tx1"/>
-          </a:solidFill>
-          <a:ln/>
-        </p:spPr>
-      </p:sp>
-      <p:sp>
-        <p:nvSpPr>
-          <p:cNvPr id="20" name="Text 18"/>
-          <p:cNvSpPr txBox="1"/>
-          <p:nvPr/>
-        </p:nvSpPr>
-        <p:spPr>
-          <a:xfrm>
-            <a:off x="685800" y="4864608"/>
-            <a:ext cx="420624" cy="420624"/>
-          </a:xfrm>
-          <a:prstGeom prst="rect">
-            <a:avLst/>
-          </a:prstGeom>
-          <a:noFill/>
-          <a:ln/>
-        </p:spPr>
-        <p:txBody>
-          <a:bodyPr wrap="square" lIns="0" tIns="0" rIns="0" bIns="0" rtlCol="0" anchor="ctr"/>
-          <a:lstStyle/>
-          <a:p>
-            <a:pPr algn="ctr" indent="0" marL="0">
-              <a:buNone/>
-            </a:pPr>
-            <a:r>
-              <a:rPr lang="en-US" sz="1400" b="1" dirty="0">
-                <a:solidFill>
-                  <a:schemeClr val="bg1"/>
-                </a:solidFill>
-              </a:rPr>
-              <a:t>1</a:t>
-            </a:r>
-            <a:endParaRPr lang="en-US" sz="1400" dirty="0"/>
-          </a:p>
-        </p:txBody>
-      </p:sp>
-      <p:sp>
-        <p:nvSpPr>
-          <p:cNvPr id="21" name="Text 19"/>
-          <p:cNvSpPr txBox="1"/>
-          <p:nvPr/>
-        </p:nvSpPr>
-        <p:spPr>
-          <a:xfrm>
-            <a:off x="1216152" y="4480560"/>
-            <a:ext cx="1325880" cy="1188720"/>
-          </a:xfrm>
-          <a:prstGeom prst="rect">
-            <a:avLst/>
-          </a:prstGeom>
-          <a:noFill/>
-          <a:ln/>
-        </p:spPr>
-        <p:txBody>
-          <a:bodyPr wrap="square" lIns="0" tIns="0" rIns="0" bIns="0" rtlCol="0" anchor="ctr"/>
-          <a:lstStyle/>
-          <a:p>
-            <a:pPr indent="0" marL="0">
-              <a:buNone/>
-            </a:pPr>
-            <a:r>
-              <a:rPr lang="en-US" sz="1400" b="1" dirty="0">
-                <a:solidFill>
-                  <a:schemeClr val="tx1"/>
-                </a:solidFill>
-              </a:rPr>
-              <a:t>Prompt Battle</a:t>
-            </a:r>
-            <a:endParaRPr lang="en-US" sz="1400" dirty="0"/>
-          </a:p>
-        </p:txBody>
-      </p:sp>
-      <p:sp>
-        <p:nvSpPr>
-          <p:cNvPr id="22" name="Station 2"/>
-          <p:cNvSpPr/>
-          <p:nvPr/>
-        </p:nvSpPr>
-        <p:spPr>
-          <a:xfrm>
-            <a:off x="2752344" y="4480560"/>
-            <a:ext cx="2103120" cy="1188720"/>
+            <a:off x="4279392" y="4480560"/>
+            <a:ext cx="3611880" cy="1280160"/>
           </a:xfrm>
           <a:prstGeom prst="roundRect">
             <a:avLst>
-              <a:gd name="adj" fmla="val 9231"/>
+              <a:gd name="adj" fmla="val 8571"/>
             </a:avLst>
           </a:prstGeom>
           <a:solidFill>
@@ -16948,110 +17138,126 @@
       </p:sp>
       <p:sp>
         <p:nvSpPr>
-          <p:cNvPr id="23" name="Nummer 2"/>
+          <p:cNvPr id="23" name="Text 21"/>
+          <p:cNvSpPr txBox="1"/>
+          <p:nvPr/>
+        </p:nvSpPr>
+        <p:spPr>
+          <a:xfrm>
+            <a:off x="4553712" y="4590288"/>
+            <a:ext cx="3108960" cy="274320"/>
+          </a:xfrm>
+          <a:prstGeom prst="rect">
+            <a:avLst/>
+          </a:prstGeom>
+          <a:noFill/>
+          <a:ln/>
+        </p:spPr>
+        <p:txBody>
+          <a:bodyPr wrap="square" lIns="0" tIns="0" rIns="0" bIns="0" rtlCol="0" anchor="ctr"/>
+          <a:lstStyle/>
+          <a:p>
+            <a:pPr indent="0" marL="0">
+              <a:buNone/>
+            </a:pPr>
+            <a:r>
+              <a:rPr lang="en-US" sz="1000" b="1" spc="200" kern="0" dirty="0">
+                <a:solidFill>
+                  <a:schemeClr val="accent1"/>
+                </a:solidFill>
+              </a:rPr>
+              <a:t>RAUM 2</a:t>
+            </a:r>
+            <a:endParaRPr lang="en-US" sz="1000" dirty="0"/>
+          </a:p>
+        </p:txBody>
+      </p:sp>
+      <p:sp>
+        <p:nvSpPr>
+          <p:cNvPr id="24" name="Text 22"/>
+          <p:cNvSpPr txBox="1"/>
+          <p:nvPr/>
+        </p:nvSpPr>
+        <p:spPr>
+          <a:xfrm>
+            <a:off x="4553712" y="4846320"/>
+            <a:ext cx="3108960" cy="411480"/>
+          </a:xfrm>
+          <a:prstGeom prst="rect">
+            <a:avLst/>
+          </a:prstGeom>
+          <a:noFill/>
+          <a:ln/>
+        </p:spPr>
+        <p:txBody>
+          <a:bodyPr wrap="square" lIns="0" tIns="0" rIns="0" bIns="0" rtlCol="0" anchor="ctr"/>
+          <a:lstStyle/>
+          <a:p>
+            <a:pPr indent="0" marL="0">
+              <a:buNone/>
+            </a:pPr>
+            <a:r>
+              <a:rPr lang="en-US" sz="1800" b="1" dirty="0">
+                <a:solidFill>
+                  <a:schemeClr val="tx1"/>
+                </a:solidFill>
+              </a:rPr>
+              <a:t>KI prüfen</a:t>
+            </a:r>
+            <a:endParaRPr lang="en-US" sz="1800" dirty="0"/>
+          </a:p>
+        </p:txBody>
+      </p:sp>
+      <p:sp>
+        <p:nvSpPr>
+          <p:cNvPr id="25" name="Text 23"/>
+          <p:cNvSpPr txBox="1"/>
+          <p:nvPr/>
+        </p:nvSpPr>
+        <p:spPr>
+          <a:xfrm>
+            <a:off x="4553712" y="5285232"/>
+            <a:ext cx="3200400" cy="320040"/>
+          </a:xfrm>
+          <a:prstGeom prst="rect">
+            <a:avLst/>
+          </a:prstGeom>
+          <a:noFill/>
+          <a:ln/>
+        </p:spPr>
+        <p:txBody>
+          <a:bodyPr wrap="square" lIns="0" tIns="0" rIns="0" bIns="0" rtlCol="0" anchor="ctr"/>
+          <a:lstStyle/>
+          <a:p>
+            <a:pPr indent="0" marL="0">
+              <a:buNone/>
+            </a:pPr>
+            <a:r>
+              <a:rPr lang="en-US" sz="1200" dirty="0">
+                <a:solidFill>
+                  <a:schemeClr val="tx2"/>
+                </a:solidFill>
+              </a:rPr>
+              <a:t>KI-Faktencheck · Deepfake Detective</a:t>
+            </a:r>
+            <a:endParaRPr lang="en-US" sz="1200" dirty="0"/>
+          </a:p>
+        </p:txBody>
+      </p:sp>
+      <p:sp>
+        <p:nvSpPr>
+          <p:cNvPr id="26" name="Raum 3"/>
           <p:cNvSpPr/>
           <p:nvPr/>
         </p:nvSpPr>
         <p:spPr>
           <a:xfrm>
-            <a:off x="2953512" y="4864608"/>
-            <a:ext cx="420624" cy="420624"/>
-          </a:xfrm>
-          <a:prstGeom prst="ellipse">
-            <a:avLst/>
-          </a:prstGeom>
-          <a:solidFill>
-            <a:schemeClr val="tx1"/>
-          </a:solidFill>
-          <a:ln/>
-        </p:spPr>
-      </p:sp>
-      <p:sp>
-        <p:nvSpPr>
-          <p:cNvPr id="24" name="Text 22"/>
-          <p:cNvSpPr txBox="1"/>
-          <p:nvPr/>
-        </p:nvSpPr>
-        <p:spPr>
-          <a:xfrm>
-            <a:off x="2953512" y="4864608"/>
-            <a:ext cx="420624" cy="420624"/>
-          </a:xfrm>
-          <a:prstGeom prst="rect">
-            <a:avLst/>
-          </a:prstGeom>
-          <a:noFill/>
-          <a:ln/>
-        </p:spPr>
-        <p:txBody>
-          <a:bodyPr wrap="square" lIns="0" tIns="0" rIns="0" bIns="0" rtlCol="0" anchor="ctr"/>
-          <a:lstStyle/>
-          <a:p>
-            <a:pPr algn="ctr" indent="0" marL="0">
-              <a:buNone/>
-            </a:pPr>
-            <a:r>
-              <a:rPr lang="en-US" sz="1400" b="1" dirty="0">
-                <a:solidFill>
-                  <a:schemeClr val="bg1"/>
-                </a:solidFill>
-              </a:rPr>
-              <a:t>2</a:t>
-            </a:r>
-            <a:endParaRPr lang="en-US" sz="1400" dirty="0"/>
-          </a:p>
-        </p:txBody>
-      </p:sp>
-      <p:sp>
-        <p:nvSpPr>
-          <p:cNvPr id="25" name="Text 23"/>
-          <p:cNvSpPr txBox="1"/>
-          <p:nvPr/>
-        </p:nvSpPr>
-        <p:spPr>
-          <a:xfrm>
-            <a:off x="3483864" y="4480560"/>
-            <a:ext cx="1325880" cy="1188720"/>
-          </a:xfrm>
-          <a:prstGeom prst="rect">
-            <a:avLst/>
-          </a:prstGeom>
-          <a:noFill/>
-          <a:ln/>
-        </p:spPr>
-        <p:txBody>
-          <a:bodyPr wrap="square" lIns="0" tIns="0" rIns="0" bIns="0" rtlCol="0" anchor="ctr"/>
-          <a:lstStyle/>
-          <a:p>
-            <a:pPr indent="0" marL="0">
-              <a:buNone/>
-            </a:pPr>
-            <a:r>
-              <a:rPr lang="en-US" sz="1400" b="1" dirty="0">
-                <a:solidFill>
-                  <a:schemeClr val="tx1"/>
-                </a:solidFill>
-              </a:rPr>
-              <a:t>KI als Lerncoach</a:t>
-            </a:r>
-            <a:endParaRPr lang="en-US" sz="1400" dirty="0"/>
-          </a:p>
-        </p:txBody>
-      </p:sp>
-      <p:sp>
-        <p:nvSpPr>
-          <p:cNvPr id="26" name="Station 3"/>
-          <p:cNvSpPr/>
-          <p:nvPr/>
-        </p:nvSpPr>
-        <p:spPr>
-          <a:xfrm>
-            <a:off x="5020056" y="4480560"/>
-            <a:ext cx="2103120" cy="1188720"/>
+            <a:off x="8074152" y="4480560"/>
+            <a:ext cx="3611880" cy="1280160"/>
           </a:xfrm>
           <a:prstGeom prst="roundRect">
             <a:avLst>
-              <a:gd name="adj" fmla="val 9231"/>
+              <a:gd name="adj" fmla="val 8571"/>
             </a:avLst>
           </a:prstGeom>
           <a:solidFill>
@@ -17062,23 +17268,39 @@
       </p:sp>
       <p:sp>
         <p:nvSpPr>
-          <p:cNvPr id="27" name="Nummer 3"/>
-          <p:cNvSpPr/>
-          <p:nvPr/>
-        </p:nvSpPr>
-        <p:spPr>
-          <a:xfrm>
-            <a:off x="5221224" y="4864608"/>
-            <a:ext cx="420624" cy="420624"/>
-          </a:xfrm>
-          <a:prstGeom prst="ellipse">
-            <a:avLst/>
-          </a:prstGeom>
-          <a:solidFill>
-            <a:schemeClr val="tx1"/>
-          </a:solidFill>
-          <a:ln/>
-        </p:spPr>
+          <p:cNvPr id="27" name="Text 25"/>
+          <p:cNvSpPr txBox="1"/>
+          <p:nvPr/>
+        </p:nvSpPr>
+        <p:spPr>
+          <a:xfrm>
+            <a:off x="8348472" y="4590288"/>
+            <a:ext cx="3108960" cy="274320"/>
+          </a:xfrm>
+          <a:prstGeom prst="rect">
+            <a:avLst/>
+          </a:prstGeom>
+          <a:noFill/>
+          <a:ln/>
+        </p:spPr>
+        <p:txBody>
+          <a:bodyPr wrap="square" lIns="0" tIns="0" rIns="0" bIns="0" rtlCol="0" anchor="ctr"/>
+          <a:lstStyle/>
+          <a:p>
+            <a:pPr indent="0" marL="0">
+              <a:buNone/>
+            </a:pPr>
+            <a:r>
+              <a:rPr lang="en-US" sz="1000" b="1" spc="200" kern="0" dirty="0">
+                <a:solidFill>
+                  <a:schemeClr val="accent1"/>
+                </a:solidFill>
+              </a:rPr>
+              <a:t>RAUM 3</a:t>
+            </a:r>
+            <a:endParaRPr lang="en-US" sz="1000" dirty="0"/>
+          </a:p>
+        </p:txBody>
       </p:sp>
       <p:sp>
         <p:nvSpPr>
@@ -17088,8 +17310,8 @@
         </p:nvSpPr>
         <p:spPr>
           <a:xfrm>
-            <a:off x="5221224" y="4864608"/>
-            <a:ext cx="420624" cy="420624"/>
+            <a:off x="8348472" y="4846320"/>
+            <a:ext cx="3108960" cy="411480"/>
           </a:xfrm>
           <a:prstGeom prst="rect">
             <a:avLst/>
@@ -17101,18 +17323,18 @@
           <a:bodyPr wrap="square" lIns="0" tIns="0" rIns="0" bIns="0" rtlCol="0" anchor="ctr"/>
           <a:lstStyle/>
           <a:p>
-            <a:pPr algn="ctr" indent="0" marL="0">
-              <a:buNone/>
-            </a:pPr>
-            <a:r>
-              <a:rPr lang="en-US" sz="1400" b="1" dirty="0">
-                <a:solidFill>
-                  <a:schemeClr val="bg1"/>
-                </a:solidFill>
-              </a:rPr>
-              <a:t>3</a:t>
-            </a:r>
-            <a:endParaRPr lang="en-US" sz="1400" dirty="0"/>
+            <a:pPr indent="0" marL="0">
+              <a:buNone/>
+            </a:pPr>
+            <a:r>
+              <a:rPr lang="en-US" sz="1800" b="1" dirty="0">
+                <a:solidFill>
+                  <a:schemeClr val="tx1"/>
+                </a:solidFill>
+              </a:rPr>
+              <a:t>KI gestalten</a:t>
+            </a:r>
+            <a:endParaRPr lang="en-US" sz="1800" dirty="0"/>
           </a:p>
         </p:txBody>
       </p:sp>
@@ -17124,8 +17346,8 @@
         </p:nvSpPr>
         <p:spPr>
           <a:xfrm>
-            <a:off x="5751576" y="4480560"/>
-            <a:ext cx="1325880" cy="1188720"/>
+            <a:off x="8348472" y="5285232"/>
+            <a:ext cx="3200400" cy="320040"/>
           </a:xfrm>
           <a:prstGeom prst="rect">
             <a:avLst/>
@@ -17141,242 +17363,14 @@
               <a:buNone/>
             </a:pPr>
             <a:r>
-              <a:rPr lang="en-US" sz="1400" b="1" dirty="0">
-                <a:solidFill>
-                  <a:schemeClr val="tx1"/>
-                </a:solidFill>
-              </a:rPr>
-              <a:t>KI-Faktencheck</a:t>
-            </a:r>
-            <a:endParaRPr lang="en-US" sz="1400" dirty="0"/>
-          </a:p>
-        </p:txBody>
-      </p:sp>
-      <p:sp>
-        <p:nvSpPr>
-          <p:cNvPr id="30" name="Station 4"/>
-          <p:cNvSpPr/>
-          <p:nvPr/>
-        </p:nvSpPr>
-        <p:spPr>
-          <a:xfrm>
-            <a:off x="7287768" y="4480560"/>
-            <a:ext cx="2103120" cy="1188720"/>
-          </a:xfrm>
-          <a:prstGeom prst="roundRect">
-            <a:avLst>
-              <a:gd name="adj" fmla="val 9231"/>
-            </a:avLst>
-          </a:prstGeom>
-          <a:solidFill>
-            <a:schemeClr val="bg2"/>
-          </a:solidFill>
-          <a:ln/>
-        </p:spPr>
-      </p:sp>
-      <p:sp>
-        <p:nvSpPr>
-          <p:cNvPr id="31" name="Nummer 4"/>
-          <p:cNvSpPr/>
-          <p:nvPr/>
-        </p:nvSpPr>
-        <p:spPr>
-          <a:xfrm>
-            <a:off x="7488936" y="4864608"/>
-            <a:ext cx="420624" cy="420624"/>
-          </a:xfrm>
-          <a:prstGeom prst="ellipse">
-            <a:avLst/>
-          </a:prstGeom>
-          <a:solidFill>
-            <a:schemeClr val="tx1"/>
-          </a:solidFill>
-          <a:ln/>
-        </p:spPr>
-      </p:sp>
-      <p:sp>
-        <p:nvSpPr>
-          <p:cNvPr id="32" name="Text 30"/>
-          <p:cNvSpPr txBox="1"/>
-          <p:nvPr/>
-        </p:nvSpPr>
-        <p:spPr>
-          <a:xfrm>
-            <a:off x="7488936" y="4864608"/>
-            <a:ext cx="420624" cy="420624"/>
-          </a:xfrm>
-          <a:prstGeom prst="rect">
-            <a:avLst/>
-          </a:prstGeom>
-          <a:noFill/>
-          <a:ln/>
-        </p:spPr>
-        <p:txBody>
-          <a:bodyPr wrap="square" lIns="0" tIns="0" rIns="0" bIns="0" rtlCol="0" anchor="ctr"/>
-          <a:lstStyle/>
-          <a:p>
-            <a:pPr algn="ctr" indent="0" marL="0">
-              <a:buNone/>
-            </a:pPr>
-            <a:r>
-              <a:rPr lang="en-US" sz="1400" b="1" dirty="0">
-                <a:solidFill>
-                  <a:schemeClr val="bg1"/>
-                </a:solidFill>
-              </a:rPr>
-              <a:t>4</a:t>
-            </a:r>
-            <a:endParaRPr lang="en-US" sz="1400" dirty="0"/>
-          </a:p>
-        </p:txBody>
-      </p:sp>
-      <p:sp>
-        <p:nvSpPr>
-          <p:cNvPr id="33" name="Text 31"/>
-          <p:cNvSpPr txBox="1"/>
-          <p:nvPr/>
-        </p:nvSpPr>
-        <p:spPr>
-          <a:xfrm>
-            <a:off x="8019288" y="4480560"/>
-            <a:ext cx="1325880" cy="1188720"/>
-          </a:xfrm>
-          <a:prstGeom prst="rect">
-            <a:avLst/>
-          </a:prstGeom>
-          <a:noFill/>
-          <a:ln/>
-        </p:spPr>
-        <p:txBody>
-          <a:bodyPr wrap="square" lIns="0" tIns="0" rIns="0" bIns="0" rtlCol="0" anchor="ctr"/>
-          <a:lstStyle/>
-          <a:p>
-            <a:pPr indent="0" marL="0">
-              <a:buNone/>
-            </a:pPr>
-            <a:r>
-              <a:rPr lang="en-US" sz="1400" b="1" dirty="0">
-                <a:solidFill>
-                  <a:schemeClr val="tx1"/>
-                </a:solidFill>
-              </a:rPr>
-              <a:t>Deepfake Detective</a:t>
-            </a:r>
-            <a:endParaRPr lang="en-US" sz="1400" dirty="0"/>
-          </a:p>
-        </p:txBody>
-      </p:sp>
-      <p:sp>
-        <p:nvSpPr>
-          <p:cNvPr id="34" name="Station 5"/>
-          <p:cNvSpPr/>
-          <p:nvPr/>
-        </p:nvSpPr>
-        <p:spPr>
-          <a:xfrm>
-            <a:off x="9555480" y="4480560"/>
-            <a:ext cx="2103120" cy="1188720"/>
-          </a:xfrm>
-          <a:prstGeom prst="roundRect">
-            <a:avLst>
-              <a:gd name="adj" fmla="val 9231"/>
-            </a:avLst>
-          </a:prstGeom>
-          <a:solidFill>
-            <a:schemeClr val="bg2"/>
-          </a:solidFill>
-          <a:ln/>
-        </p:spPr>
-      </p:sp>
-      <p:sp>
-        <p:nvSpPr>
-          <p:cNvPr id="35" name="Nummer 5"/>
-          <p:cNvSpPr/>
-          <p:nvPr/>
-        </p:nvSpPr>
-        <p:spPr>
-          <a:xfrm>
-            <a:off x="9756648" y="4864608"/>
-            <a:ext cx="420624" cy="420624"/>
-          </a:xfrm>
-          <a:prstGeom prst="ellipse">
-            <a:avLst/>
-          </a:prstGeom>
-          <a:solidFill>
-            <a:schemeClr val="tx1"/>
-          </a:solidFill>
-          <a:ln/>
-        </p:spPr>
-      </p:sp>
-      <p:sp>
-        <p:nvSpPr>
-          <p:cNvPr id="36" name="Text 34"/>
-          <p:cNvSpPr txBox="1"/>
-          <p:nvPr/>
-        </p:nvSpPr>
-        <p:spPr>
-          <a:xfrm>
-            <a:off x="9756648" y="4864608"/>
-            <a:ext cx="420624" cy="420624"/>
-          </a:xfrm>
-          <a:prstGeom prst="rect">
-            <a:avLst/>
-          </a:prstGeom>
-          <a:noFill/>
-          <a:ln/>
-        </p:spPr>
-        <p:txBody>
-          <a:bodyPr wrap="square" lIns="0" tIns="0" rIns="0" bIns="0" rtlCol="0" anchor="ctr"/>
-          <a:lstStyle/>
-          <a:p>
-            <a:pPr algn="ctr" indent="0" marL="0">
-              <a:buNone/>
-            </a:pPr>
-            <a:r>
-              <a:rPr lang="en-US" sz="1400" b="1" dirty="0">
-                <a:solidFill>
-                  <a:schemeClr val="bg1"/>
-                </a:solidFill>
-              </a:rPr>
-              <a:t>5</a:t>
-            </a:r>
-            <a:endParaRPr lang="en-US" sz="1400" dirty="0"/>
-          </a:p>
-        </p:txBody>
-      </p:sp>
-      <p:sp>
-        <p:nvSpPr>
-          <p:cNvPr id="37" name="Text 35"/>
-          <p:cNvSpPr txBox="1"/>
-          <p:nvPr/>
-        </p:nvSpPr>
-        <p:spPr>
-          <a:xfrm>
-            <a:off x="10287000" y="4480560"/>
-            <a:ext cx="1325880" cy="1188720"/>
-          </a:xfrm>
-          <a:prstGeom prst="rect">
-            <a:avLst/>
-          </a:prstGeom>
-          <a:noFill/>
-          <a:ln/>
-        </p:spPr>
-        <p:txBody>
-          <a:bodyPr wrap="square" lIns="0" tIns="0" rIns="0" bIns="0" rtlCol="0" anchor="ctr"/>
-          <a:lstStyle/>
-          <a:p>
-            <a:pPr indent="0" marL="0">
-              <a:buNone/>
-            </a:pPr>
-            <a:r>
-              <a:rPr lang="en-US" sz="1400" b="1" dirty="0">
-                <a:solidFill>
-                  <a:schemeClr val="tx1"/>
+              <a:rPr lang="en-US" sz="1200" dirty="0">
+                <a:solidFill>
+                  <a:schemeClr val="tx2"/>
                 </a:solidFill>
               </a:rPr>
               <a:t>Build your AI</a:t>
             </a:r>
-            <a:endParaRPr lang="en-US" sz="1400" dirty="0"/>
+            <a:endParaRPr lang="en-US" sz="1200" dirty="0"/>
           </a:p>
         </p:txBody>
       </p:sp>

</xml_diff>